<commit_message>
Added Legal AI Research Paper source files
</commit_message>
<xml_diff>
--- a/Research paper doc/Updated Images/AI for legal case outcome prediction Updated.pptx
+++ b/Research paper doc/Updated Images/AI for legal case outcome prediction Updated.pptx
@@ -5,7 +5,7 @@
     <p:sldMasterId id="2147483696" r:id="rId1"/>
   </p:sldMasterIdLst>
   <p:notesMasterIdLst>
-    <p:notesMasterId r:id="rId18"/>
+    <p:notesMasterId r:id="rId21"/>
   </p:notesMasterIdLst>
   <p:sldIdLst>
     <p:sldId id="280" r:id="rId2"/>
@@ -19,11 +19,14 @@
     <p:sldId id="282" r:id="rId10"/>
     <p:sldId id="289" r:id="rId11"/>
     <p:sldId id="290" r:id="rId12"/>
-    <p:sldId id="297" r:id="rId13"/>
-    <p:sldId id="293" r:id="rId14"/>
-    <p:sldId id="294" r:id="rId15"/>
-    <p:sldId id="292" r:id="rId16"/>
-    <p:sldId id="298" r:id="rId17"/>
+    <p:sldId id="299" r:id="rId13"/>
+    <p:sldId id="300" r:id="rId14"/>
+    <p:sldId id="297" r:id="rId15"/>
+    <p:sldId id="293" r:id="rId16"/>
+    <p:sldId id="301" r:id="rId17"/>
+    <p:sldId id="294" r:id="rId18"/>
+    <p:sldId id="292" r:id="rId19"/>
+    <p:sldId id="298" r:id="rId20"/>
   </p:sldIdLst>
   <p:sldSz cx="9144000" cy="6858000" type="screen4x3"/>
   <p:notesSz cx="6858000" cy="9144000"/>
@@ -224,7 +227,7 @@
             <a:fld id="{DA13ADEF-1232-40E6-AA0C-2DC4E3D89003}" type="datetimeFigureOut">
               <a:rPr lang="en-GB" smtClean="0"/>
               <a:pPr/>
-              <a:t>28/03/2026</a:t>
+              <a:t>02/06/2026</a:t>
             </a:fld>
             <a:endParaRPr lang="en-GB"/>
           </a:p>
@@ -791,6 +794,246 @@
         <p:cNvPr id="1" name="">
           <a:extLst>
             <a:ext uri="{FF2B5EF4-FFF2-40B4-BE49-F238E27FC236}">
+              <a16:creationId xmlns:a16="http://schemas.microsoft.com/office/drawing/2014/main" id="{450361C1-6CF5-F101-5153-C0580E371638}"/>
+            </a:ext>
+          </a:extLst>
+        </p:cNvPr>
+        <p:cNvGrpSpPr/>
+        <p:nvPr/>
+      </p:nvGrpSpPr>
+      <p:grpSpPr>
+        <a:xfrm>
+          <a:off x="0" y="0"/>
+          <a:ext cx="0" cy="0"/>
+          <a:chOff x="0" y="0"/>
+          <a:chExt cx="0" cy="0"/>
+        </a:xfrm>
+      </p:grpSpPr>
+      <p:sp>
+        <p:nvSpPr>
+          <p:cNvPr id="1048604" name="Rectangle 7">
+            <a:extLst>
+              <a:ext uri="{FF2B5EF4-FFF2-40B4-BE49-F238E27FC236}">
+                <a16:creationId xmlns:a16="http://schemas.microsoft.com/office/drawing/2014/main" id="{121A0E3F-65C8-A419-7EA8-EDB787AB1F1B}"/>
+              </a:ext>
+            </a:extLst>
+          </p:cNvPr>
+          <p:cNvSpPr>
+            <a:spLocks noGrp="1" noChangeArrowheads="1"/>
+          </p:cNvSpPr>
+          <p:nvPr>
+            <p:ph type="sldNum" sz="quarter" idx="5"/>
+          </p:nvPr>
+        </p:nvSpPr>
+        <p:spPr/>
+        <p:txBody>
+          <a:bodyPr/>
+          <a:lstStyle/>
+          <a:p>
+            <a:fld id="{6BFD01EB-C9A3-4136-A0B1-C6AEC703FF81}" type="slidenum">
+              <a:rPr lang="en-US" smtClean="0"/>
+              <a:t>12</a:t>
+            </a:fld>
+            <a:endParaRPr lang="en-US"/>
+          </a:p>
+        </p:txBody>
+      </p:sp>
+      <p:sp>
+        <p:nvSpPr>
+          <p:cNvPr id="1048605" name="Rectangle 2">
+            <a:extLst>
+              <a:ext uri="{FF2B5EF4-FFF2-40B4-BE49-F238E27FC236}">
+                <a16:creationId xmlns:a16="http://schemas.microsoft.com/office/drawing/2014/main" id="{2F9BDB53-68AB-33C2-FD7B-CFBEF21DCB7C}"/>
+              </a:ext>
+            </a:extLst>
+          </p:cNvPr>
+          <p:cNvSpPr>
+            <a:spLocks noGrp="1" noRot="1" noChangeAspect="1" noChangeArrowheads="1" noTextEdit="1"/>
+          </p:cNvSpPr>
+          <p:nvPr>
+            <p:ph type="sldImg"/>
+          </p:nvPr>
+        </p:nvSpPr>
+        <p:spPr/>
+        <p:txBody>
+          <a:bodyPr/>
+          <a:lstStyle/>
+          <a:p>
+            <a:endParaRPr lang="en-IN"/>
+          </a:p>
+        </p:txBody>
+      </p:sp>
+      <p:sp>
+        <p:nvSpPr>
+          <p:cNvPr id="1048606" name="Rectangle 3">
+            <a:extLst>
+              <a:ext uri="{FF2B5EF4-FFF2-40B4-BE49-F238E27FC236}">
+                <a16:creationId xmlns:a16="http://schemas.microsoft.com/office/drawing/2014/main" id="{3EDBA486-409D-A2BB-D592-71F50F6B8205}"/>
+              </a:ext>
+            </a:extLst>
+          </p:cNvPr>
+          <p:cNvSpPr>
+            <a:spLocks noGrp="1" noChangeArrowheads="1"/>
+          </p:cNvSpPr>
+          <p:nvPr>
+            <p:ph type="body" idx="1"/>
+          </p:nvPr>
+        </p:nvSpPr>
+        <p:spPr>
+          <a:noFill/>
+        </p:spPr>
+        <p:txBody>
+          <a:bodyPr/>
+          <a:lstStyle/>
+          <a:p>
+            <a:pPr eaLnBrk="1" hangingPunct="1"/>
+            <a:endParaRPr lang="en-US">
+              <a:latin typeface="Arial" panose="020B0604020202020204" pitchFamily="34" charset="0"/>
+            </a:endParaRPr>
+          </a:p>
+        </p:txBody>
+      </p:sp>
+    </p:spTree>
+    <p:extLst>
+      <p:ext uri="{BB962C8B-B14F-4D97-AF65-F5344CB8AC3E}">
+        <p14:creationId xmlns:p14="http://schemas.microsoft.com/office/powerpoint/2010/main" val="4083839066"/>
+      </p:ext>
+    </p:extLst>
+  </p:cSld>
+  <p:clrMapOvr>
+    <a:masterClrMapping/>
+  </p:clrMapOvr>
+</p:notes>
+</file>
+
+<file path=ppt/notesSlides/notesSlide13.xml><?xml version="1.0" encoding="utf-8"?>
+<p:notes xmlns:a="http://schemas.openxmlformats.org/drawingml/2006/main" xmlns:r="http://schemas.openxmlformats.org/officeDocument/2006/relationships" xmlns:p="http://schemas.openxmlformats.org/presentationml/2006/main">
+  <p:cSld>
+    <p:spTree>
+      <p:nvGrpSpPr>
+        <p:cNvPr id="1" name="">
+          <a:extLst>
+            <a:ext uri="{FF2B5EF4-FFF2-40B4-BE49-F238E27FC236}">
+              <a16:creationId xmlns:a16="http://schemas.microsoft.com/office/drawing/2014/main" id="{00A9E323-FBA6-628C-4EF3-EA4C75707C5B}"/>
+            </a:ext>
+          </a:extLst>
+        </p:cNvPr>
+        <p:cNvGrpSpPr/>
+        <p:nvPr/>
+      </p:nvGrpSpPr>
+      <p:grpSpPr>
+        <a:xfrm>
+          <a:off x="0" y="0"/>
+          <a:ext cx="0" cy="0"/>
+          <a:chOff x="0" y="0"/>
+          <a:chExt cx="0" cy="0"/>
+        </a:xfrm>
+      </p:grpSpPr>
+      <p:sp>
+        <p:nvSpPr>
+          <p:cNvPr id="1048604" name="Rectangle 7">
+            <a:extLst>
+              <a:ext uri="{FF2B5EF4-FFF2-40B4-BE49-F238E27FC236}">
+                <a16:creationId xmlns:a16="http://schemas.microsoft.com/office/drawing/2014/main" id="{F0BE73F3-4A1F-7623-7339-3375E9E0D757}"/>
+              </a:ext>
+            </a:extLst>
+          </p:cNvPr>
+          <p:cNvSpPr>
+            <a:spLocks noGrp="1" noChangeArrowheads="1"/>
+          </p:cNvSpPr>
+          <p:nvPr>
+            <p:ph type="sldNum" sz="quarter" idx="5"/>
+          </p:nvPr>
+        </p:nvSpPr>
+        <p:spPr/>
+        <p:txBody>
+          <a:bodyPr/>
+          <a:lstStyle/>
+          <a:p>
+            <a:fld id="{6BFD01EB-C9A3-4136-A0B1-C6AEC703FF81}" type="slidenum">
+              <a:rPr lang="en-US" smtClean="0"/>
+              <a:t>13</a:t>
+            </a:fld>
+            <a:endParaRPr lang="en-US"/>
+          </a:p>
+        </p:txBody>
+      </p:sp>
+      <p:sp>
+        <p:nvSpPr>
+          <p:cNvPr id="1048605" name="Rectangle 2">
+            <a:extLst>
+              <a:ext uri="{FF2B5EF4-FFF2-40B4-BE49-F238E27FC236}">
+                <a16:creationId xmlns:a16="http://schemas.microsoft.com/office/drawing/2014/main" id="{161CE5EA-2E8D-3E77-3160-3A46F57A1132}"/>
+              </a:ext>
+            </a:extLst>
+          </p:cNvPr>
+          <p:cNvSpPr>
+            <a:spLocks noGrp="1" noRot="1" noChangeAspect="1" noChangeArrowheads="1" noTextEdit="1"/>
+          </p:cNvSpPr>
+          <p:nvPr>
+            <p:ph type="sldImg"/>
+          </p:nvPr>
+        </p:nvSpPr>
+        <p:spPr/>
+        <p:txBody>
+          <a:bodyPr/>
+          <a:lstStyle/>
+          <a:p>
+            <a:endParaRPr lang="en-IN"/>
+          </a:p>
+        </p:txBody>
+      </p:sp>
+      <p:sp>
+        <p:nvSpPr>
+          <p:cNvPr id="1048606" name="Rectangle 3">
+            <a:extLst>
+              <a:ext uri="{FF2B5EF4-FFF2-40B4-BE49-F238E27FC236}">
+                <a16:creationId xmlns:a16="http://schemas.microsoft.com/office/drawing/2014/main" id="{3F031AFA-F9E1-BC2E-4EA3-18D0C1B00201}"/>
+              </a:ext>
+            </a:extLst>
+          </p:cNvPr>
+          <p:cNvSpPr>
+            <a:spLocks noGrp="1" noChangeArrowheads="1"/>
+          </p:cNvSpPr>
+          <p:nvPr>
+            <p:ph type="body" idx="1"/>
+          </p:nvPr>
+        </p:nvSpPr>
+        <p:spPr>
+          <a:noFill/>
+        </p:spPr>
+        <p:txBody>
+          <a:bodyPr/>
+          <a:lstStyle/>
+          <a:p>
+            <a:pPr eaLnBrk="1" hangingPunct="1"/>
+            <a:endParaRPr lang="en-US">
+              <a:latin typeface="Arial" panose="020B0604020202020204" pitchFamily="34" charset="0"/>
+            </a:endParaRPr>
+          </a:p>
+        </p:txBody>
+      </p:sp>
+    </p:spTree>
+    <p:extLst>
+      <p:ext uri="{BB962C8B-B14F-4D97-AF65-F5344CB8AC3E}">
+        <p14:creationId xmlns:p14="http://schemas.microsoft.com/office/powerpoint/2010/main" val="3986794253"/>
+      </p:ext>
+    </p:extLst>
+  </p:cSld>
+  <p:clrMapOvr>
+    <a:masterClrMapping/>
+  </p:clrMapOvr>
+</p:notes>
+</file>
+
+<file path=ppt/notesSlides/notesSlide14.xml><?xml version="1.0" encoding="utf-8"?>
+<p:notes xmlns:a="http://schemas.openxmlformats.org/drawingml/2006/main" xmlns:r="http://schemas.openxmlformats.org/officeDocument/2006/relationships" xmlns:p="http://schemas.openxmlformats.org/presentationml/2006/main">
+  <p:cSld>
+    <p:spTree>
+      <p:nvGrpSpPr>
+        <p:cNvPr id="1" name="">
+          <a:extLst>
+            <a:ext uri="{FF2B5EF4-FFF2-40B4-BE49-F238E27FC236}">
               <a16:creationId xmlns:a16="http://schemas.microsoft.com/office/drawing/2014/main" id="{9B53AEB9-6845-9DD1-2F2C-7037C4818446}"/>
             </a:ext>
           </a:extLst>
@@ -829,7 +1072,7 @@
           <a:p>
             <a:fld id="{6BFD01EB-C9A3-4136-A0B1-C6AEC703FF81}" type="slidenum">
               <a:rPr lang="en-US" smtClean="0"/>
-              <a:t>12</a:t>
+              <a:t>14</a:t>
             </a:fld>
             <a:endParaRPr lang="en-US"/>
           </a:p>
@@ -903,7 +1146,7 @@
 </p:notes>
 </file>
 
-<file path=ppt/notesSlides/notesSlide13.xml><?xml version="1.0" encoding="utf-8"?>
+<file path=ppt/notesSlides/notesSlide15.xml><?xml version="1.0" encoding="utf-8"?>
 <p:notes xmlns:a="http://schemas.openxmlformats.org/drawingml/2006/main" xmlns:r="http://schemas.openxmlformats.org/officeDocument/2006/relationships" xmlns:p="http://schemas.openxmlformats.org/presentationml/2006/main">
   <p:cSld>
     <p:spTree>
@@ -949,7 +1192,7 @@
           <a:p>
             <a:fld id="{6BFD01EB-C9A3-4136-A0B1-C6AEC703FF81}" type="slidenum">
               <a:rPr lang="en-US" smtClean="0"/>
-              <a:t>13</a:t>
+              <a:t>15</a:t>
             </a:fld>
             <a:endParaRPr lang="en-US"/>
           </a:p>
@@ -1023,7 +1266,127 @@
 </p:notes>
 </file>
 
-<file path=ppt/notesSlides/notesSlide14.xml><?xml version="1.0" encoding="utf-8"?>
+<file path=ppt/notesSlides/notesSlide16.xml><?xml version="1.0" encoding="utf-8"?>
+<p:notes xmlns:a="http://schemas.openxmlformats.org/drawingml/2006/main" xmlns:r="http://schemas.openxmlformats.org/officeDocument/2006/relationships" xmlns:p="http://schemas.openxmlformats.org/presentationml/2006/main">
+  <p:cSld>
+    <p:spTree>
+      <p:nvGrpSpPr>
+        <p:cNvPr id="1" name="">
+          <a:extLst>
+            <a:ext uri="{FF2B5EF4-FFF2-40B4-BE49-F238E27FC236}">
+              <a16:creationId xmlns:a16="http://schemas.microsoft.com/office/drawing/2014/main" id="{F9A308A7-7F8C-7350-B391-7EAE36DB566E}"/>
+            </a:ext>
+          </a:extLst>
+        </p:cNvPr>
+        <p:cNvGrpSpPr/>
+        <p:nvPr/>
+      </p:nvGrpSpPr>
+      <p:grpSpPr>
+        <a:xfrm>
+          <a:off x="0" y="0"/>
+          <a:ext cx="0" cy="0"/>
+          <a:chOff x="0" y="0"/>
+          <a:chExt cx="0" cy="0"/>
+        </a:xfrm>
+      </p:grpSpPr>
+      <p:sp>
+        <p:nvSpPr>
+          <p:cNvPr id="1048604" name="Rectangle 7">
+            <a:extLst>
+              <a:ext uri="{FF2B5EF4-FFF2-40B4-BE49-F238E27FC236}">
+                <a16:creationId xmlns:a16="http://schemas.microsoft.com/office/drawing/2014/main" id="{08D9BF5F-C235-94FE-FD60-2B60B1C63E6A}"/>
+              </a:ext>
+            </a:extLst>
+          </p:cNvPr>
+          <p:cNvSpPr>
+            <a:spLocks noGrp="1" noChangeArrowheads="1"/>
+          </p:cNvSpPr>
+          <p:nvPr>
+            <p:ph type="sldNum" sz="quarter" idx="5"/>
+          </p:nvPr>
+        </p:nvSpPr>
+        <p:spPr/>
+        <p:txBody>
+          <a:bodyPr/>
+          <a:lstStyle/>
+          <a:p>
+            <a:fld id="{6BFD01EB-C9A3-4136-A0B1-C6AEC703FF81}" type="slidenum">
+              <a:rPr lang="en-US" smtClean="0"/>
+              <a:t>16</a:t>
+            </a:fld>
+            <a:endParaRPr lang="en-US"/>
+          </a:p>
+        </p:txBody>
+      </p:sp>
+      <p:sp>
+        <p:nvSpPr>
+          <p:cNvPr id="1048605" name="Rectangle 2">
+            <a:extLst>
+              <a:ext uri="{FF2B5EF4-FFF2-40B4-BE49-F238E27FC236}">
+                <a16:creationId xmlns:a16="http://schemas.microsoft.com/office/drawing/2014/main" id="{E3B9F892-D604-5467-111F-6182E02FA797}"/>
+              </a:ext>
+            </a:extLst>
+          </p:cNvPr>
+          <p:cNvSpPr>
+            <a:spLocks noGrp="1" noRot="1" noChangeAspect="1" noChangeArrowheads="1" noTextEdit="1"/>
+          </p:cNvSpPr>
+          <p:nvPr>
+            <p:ph type="sldImg"/>
+          </p:nvPr>
+        </p:nvSpPr>
+        <p:spPr/>
+        <p:txBody>
+          <a:bodyPr/>
+          <a:lstStyle/>
+          <a:p>
+            <a:endParaRPr lang="en-IN"/>
+          </a:p>
+        </p:txBody>
+      </p:sp>
+      <p:sp>
+        <p:nvSpPr>
+          <p:cNvPr id="1048606" name="Rectangle 3">
+            <a:extLst>
+              <a:ext uri="{FF2B5EF4-FFF2-40B4-BE49-F238E27FC236}">
+                <a16:creationId xmlns:a16="http://schemas.microsoft.com/office/drawing/2014/main" id="{31D60C49-2AE9-3BFD-0F33-C6190F7254BD}"/>
+              </a:ext>
+            </a:extLst>
+          </p:cNvPr>
+          <p:cNvSpPr>
+            <a:spLocks noGrp="1" noChangeArrowheads="1"/>
+          </p:cNvSpPr>
+          <p:nvPr>
+            <p:ph type="body" idx="1"/>
+          </p:nvPr>
+        </p:nvSpPr>
+        <p:spPr>
+          <a:noFill/>
+        </p:spPr>
+        <p:txBody>
+          <a:bodyPr/>
+          <a:lstStyle/>
+          <a:p>
+            <a:pPr eaLnBrk="1" hangingPunct="1"/>
+            <a:endParaRPr lang="en-US">
+              <a:latin typeface="Arial" panose="020B0604020202020204" pitchFamily="34" charset="0"/>
+            </a:endParaRPr>
+          </a:p>
+        </p:txBody>
+      </p:sp>
+    </p:spTree>
+    <p:extLst>
+      <p:ext uri="{BB962C8B-B14F-4D97-AF65-F5344CB8AC3E}">
+        <p14:creationId xmlns:p14="http://schemas.microsoft.com/office/powerpoint/2010/main" val="1936036885"/>
+      </p:ext>
+    </p:extLst>
+  </p:cSld>
+  <p:clrMapOvr>
+    <a:masterClrMapping/>
+  </p:clrMapOvr>
+</p:notes>
+</file>
+
+<file path=ppt/notesSlides/notesSlide17.xml><?xml version="1.0" encoding="utf-8"?>
 <p:notes xmlns:a="http://schemas.openxmlformats.org/drawingml/2006/main" xmlns:r="http://schemas.openxmlformats.org/officeDocument/2006/relationships" xmlns:p="http://schemas.openxmlformats.org/presentationml/2006/main">
   <p:cSld>
     <p:spTree>
@@ -1069,7 +1432,7 @@
           <a:p>
             <a:fld id="{6BFD01EB-C9A3-4136-A0B1-C6AEC703FF81}" type="slidenum">
               <a:rPr lang="en-US" smtClean="0"/>
-              <a:t>14</a:t>
+              <a:t>17</a:t>
             </a:fld>
             <a:endParaRPr lang="en-US"/>
           </a:p>
@@ -1143,7 +1506,7 @@
 </p:notes>
 </file>
 
-<file path=ppt/notesSlides/notesSlide15.xml><?xml version="1.0" encoding="utf-8"?>
+<file path=ppt/notesSlides/notesSlide18.xml><?xml version="1.0" encoding="utf-8"?>
 <p:notes xmlns:a="http://schemas.openxmlformats.org/drawingml/2006/main" xmlns:r="http://schemas.openxmlformats.org/officeDocument/2006/relationships" xmlns:p="http://schemas.openxmlformats.org/presentationml/2006/main">
   <p:cSld>
     <p:spTree>
@@ -1177,7 +1540,7 @@
           <a:p>
             <a:fld id="{6BFD01EB-C9A3-4136-A0B1-C6AEC703FF81}" type="slidenum">
               <a:rPr lang="en-US" smtClean="0"/>
-              <a:t>15</a:t>
+              <a:t>18</a:t>
             </a:fld>
             <a:endParaRPr lang="en-US"/>
           </a:p>
@@ -1239,7 +1602,7 @@
 </p:notes>
 </file>
 
-<file path=ppt/notesSlides/notesSlide16.xml><?xml version="1.0" encoding="utf-8"?>
+<file path=ppt/notesSlides/notesSlide19.xml><?xml version="1.0" encoding="utf-8"?>
 <p:notes xmlns:a="http://schemas.openxmlformats.org/drawingml/2006/main" xmlns:r="http://schemas.openxmlformats.org/officeDocument/2006/relationships" xmlns:p="http://schemas.openxmlformats.org/presentationml/2006/main">
   <p:cSld>
     <p:spTree>
@@ -1285,7 +1648,7 @@
           <a:p>
             <a:fld id="{6BFD01EB-C9A3-4136-A0B1-C6AEC703FF81}" type="slidenum">
               <a:rPr lang="en-US" smtClean="0"/>
-              <a:t>16</a:t>
+              <a:t>19</a:t>
             </a:fld>
             <a:endParaRPr lang="en-US"/>
           </a:p>
@@ -2308,7 +2671,7 @@
           <a:p>
             <a:fld id="{93EE43D5-2594-4735-80B7-F0E4544112AC}" type="datetime1">
               <a:rPr lang="en-GB" smtClean="0"/>
-              <a:t>28/03/2026</a:t>
+              <a:t>02/06/2026</a:t>
             </a:fld>
             <a:endParaRPr lang="en-GB"/>
           </a:p>
@@ -2477,7 +2840,7 @@
           <a:p>
             <a:fld id="{D90ED07B-0D58-4238-8D9E-3917EDEFBF11}" type="datetime1">
               <a:rPr lang="en-GB" smtClean="0"/>
-              <a:t>28/03/2026</a:t>
+              <a:t>02/06/2026</a:t>
             </a:fld>
             <a:endParaRPr lang="en-GB"/>
           </a:p>
@@ -2656,7 +3019,7 @@
           <a:p>
             <a:fld id="{0B15D4D9-60EA-4115-9F62-3D25530A60C4}" type="datetime1">
               <a:rPr lang="en-GB" smtClean="0"/>
-              <a:t>28/03/2026</a:t>
+              <a:t>02/06/2026</a:t>
             </a:fld>
             <a:endParaRPr lang="en-GB"/>
           </a:p>
@@ -2825,7 +3188,7 @@
           <a:p>
             <a:fld id="{A33F980D-9641-4D55-BA26-2EDCEA9EE1F9}" type="datetime1">
               <a:rPr lang="en-GB" smtClean="0"/>
-              <a:t>28/03/2026</a:t>
+              <a:t>02/06/2026</a:t>
             </a:fld>
             <a:endParaRPr lang="en-GB"/>
           </a:p>
@@ -3070,7 +3433,7 @@
           <a:p>
             <a:fld id="{862637F8-03A0-4970-9A0A-BCE5C1C1EC0E}" type="datetime1">
               <a:rPr lang="en-GB" smtClean="0"/>
-              <a:t>28/03/2026</a:t>
+              <a:t>02/06/2026</a:t>
             </a:fld>
             <a:endParaRPr lang="en-GB"/>
           </a:p>
@@ -3357,7 +3720,7 @@
           <a:p>
             <a:fld id="{DAAD62D7-D6ED-44F8-A2FC-AD370DF5A044}" type="datetime1">
               <a:rPr lang="en-GB" smtClean="0"/>
-              <a:t>28/03/2026</a:t>
+              <a:t>02/06/2026</a:t>
             </a:fld>
             <a:endParaRPr lang="en-GB"/>
           </a:p>
@@ -3778,7 +4141,7 @@
           <a:p>
             <a:fld id="{A74D6229-4D31-4440-844B-D28A91210DCE}" type="datetime1">
               <a:rPr lang="en-GB" smtClean="0"/>
-              <a:t>28/03/2026</a:t>
+              <a:t>02/06/2026</a:t>
             </a:fld>
             <a:endParaRPr lang="en-GB"/>
           </a:p>
@@ -3895,7 +4258,7 @@
           <a:p>
             <a:fld id="{06EB690D-B474-4F2D-8063-C3D6525BFDB7}" type="datetime1">
               <a:rPr lang="en-GB" smtClean="0"/>
-              <a:t>28/03/2026</a:t>
+              <a:t>02/06/2026</a:t>
             </a:fld>
             <a:endParaRPr lang="en-GB"/>
           </a:p>
@@ -3989,7 +4352,7 @@
           <a:p>
             <a:fld id="{965D96AC-A833-40E3-8856-0B511BFD0B34}" type="datetime1">
               <a:rPr lang="en-GB" smtClean="0"/>
-              <a:t>28/03/2026</a:t>
+              <a:t>02/06/2026</a:t>
             </a:fld>
             <a:endParaRPr lang="en-GB"/>
           </a:p>
@@ -4265,7 +4628,7 @@
           <a:p>
             <a:fld id="{6F20C083-5B51-4A6F-8A8D-25BF65281288}" type="datetime1">
               <a:rPr lang="en-GB" smtClean="0"/>
-              <a:t>28/03/2026</a:t>
+              <a:t>02/06/2026</a:t>
             </a:fld>
             <a:endParaRPr lang="en-GB"/>
           </a:p>
@@ -4517,7 +4880,7 @@
           <a:p>
             <a:fld id="{74158CEF-DEAA-4FD7-A123-4034F0FFBE51}" type="datetime1">
               <a:rPr lang="en-GB" smtClean="0"/>
-              <a:t>28/03/2026</a:t>
+              <a:t>02/06/2026</a:t>
             </a:fld>
             <a:endParaRPr lang="en-GB"/>
           </a:p>
@@ -4729,7 +5092,7 @@
           <a:p>
             <a:fld id="{EE03102E-B0BC-4EBE-905A-EE89488B9FC5}" type="datetime1">
               <a:rPr lang="en-GB" smtClean="0"/>
-              <a:t>28/03/2026</a:t>
+              <a:t>02/06/2026</a:t>
             </a:fld>
             <a:endParaRPr lang="en-GB"/>
           </a:p>
@@ -5263,8 +5626,8 @@
         </p:nvSpPr>
         <p:spPr bwMode="auto">
           <a:xfrm>
-            <a:off x="36512" y="1052736"/>
-            <a:ext cx="9144000" cy="338554"/>
+            <a:off x="0" y="1052735"/>
+            <a:ext cx="9180512" cy="338554"/>
           </a:xfrm>
           <a:prstGeom prst="rect">
             <a:avLst/>
@@ -5289,7 +5652,7 @@
                 <a:latin typeface="Times New Roman" panose="02020603050405020304" pitchFamily="18" charset="0"/>
                 <a:cs typeface="Times New Roman" panose="02020603050405020304" pitchFamily="18" charset="0"/>
               </a:rPr>
-              <a:t>Review -IV</a:t>
+              <a:t>Final Presentation </a:t>
             </a:r>
             <a:endParaRPr lang="en-IN" sz="1600" b="1" dirty="0">
               <a:latin typeface="Times New Roman" panose="02020603050405020304" pitchFamily="18" charset="0"/>
@@ -7179,6 +7542,57 @@
           </a:graphicData>
         </a:graphic>
       </p:graphicFrame>
+      <p:sp>
+        <p:nvSpPr>
+          <p:cNvPr id="4" name="TextBox 7">
+            <a:extLst>
+              <a:ext uri="{FF2B5EF4-FFF2-40B4-BE49-F238E27FC236}">
+                <a16:creationId xmlns:a16="http://schemas.microsoft.com/office/drawing/2014/main" id="{1244F5CA-FE8F-9A4A-5B4A-437F4ADBA3F0}"/>
+              </a:ext>
+            </a:extLst>
+          </p:cNvPr>
+          <p:cNvSpPr txBox="1">
+            <a:spLocks noChangeArrowheads="1"/>
+          </p:cNvSpPr>
+          <p:nvPr/>
+        </p:nvSpPr>
+        <p:spPr bwMode="auto">
+          <a:xfrm>
+            <a:off x="0" y="1052735"/>
+            <a:ext cx="9180512" cy="338554"/>
+          </a:xfrm>
+          <a:prstGeom prst="rect">
+            <a:avLst/>
+          </a:prstGeom>
+          <a:solidFill>
+            <a:srgbClr val="FFC000"/>
+          </a:solidFill>
+          <a:ln w="9525">
+            <a:noFill/>
+            <a:miter lim="800000"/>
+          </a:ln>
+        </p:spPr>
+        <p:txBody>
+          <a:bodyPr wrap="square">
+            <a:spAutoFit/>
+          </a:bodyPr>
+          <a:lstStyle/>
+          <a:p>
+            <a:pPr algn="ctr"/>
+            <a:r>
+              <a:rPr lang="en-US" sz="1600" b="1" dirty="0">
+                <a:latin typeface="Times New Roman" panose="02020603050405020304" pitchFamily="18" charset="0"/>
+                <a:cs typeface="Times New Roman" panose="02020603050405020304" pitchFamily="18" charset="0"/>
+              </a:rPr>
+              <a:t>Final Presentation </a:t>
+            </a:r>
+            <a:endParaRPr lang="en-IN" sz="1600" b="1" dirty="0">
+              <a:latin typeface="Times New Roman" panose="02020603050405020304" pitchFamily="18" charset="0"/>
+              <a:cs typeface="Times New Roman" panose="02020603050405020304" pitchFamily="18" charset="0"/>
+            </a:endParaRPr>
+          </a:p>
+        </p:txBody>
+      </p:sp>
     </p:spTree>
     <p:extLst>
       <p:ext uri="{BB962C8B-B14F-4D97-AF65-F5344CB8AC3E}">
@@ -7517,10 +7931,10 @@
       </p:sp>
       <p:pic>
         <p:nvPicPr>
-          <p:cNvPr id="5" name="Picture 4">
+          <p:cNvPr id="6" name="Picture 5">
             <a:extLst>
               <a:ext uri="{FF2B5EF4-FFF2-40B4-BE49-F238E27FC236}">
-                <a16:creationId xmlns:a16="http://schemas.microsoft.com/office/drawing/2014/main" id="{4D703A66-23CF-57D3-A9A3-64B9E4E5E3AD}"/>
+                <a16:creationId xmlns:a16="http://schemas.microsoft.com/office/drawing/2014/main" id="{E1E28AD4-7565-BE2F-6F0C-1EB2D24852F6}"/>
               </a:ext>
             </a:extLst>
           </p:cNvPr>
@@ -7543,14 +7957,70 @@
         </p:blipFill>
         <p:spPr>
           <a:xfrm>
-            <a:off x="251520" y="2300371"/>
-            <a:ext cx="8712968" cy="3792925"/>
+            <a:off x="467688" y="2358507"/>
+            <a:ext cx="8208768" cy="3590773"/>
           </a:xfrm>
           <a:prstGeom prst="rect">
             <a:avLst/>
           </a:prstGeom>
+          <a:ln>
+            <a:solidFill>
+              <a:schemeClr val="tx1"/>
+            </a:solidFill>
+          </a:ln>
         </p:spPr>
       </p:pic>
+      <p:sp>
+        <p:nvSpPr>
+          <p:cNvPr id="7" name="TextBox 7">
+            <a:extLst>
+              <a:ext uri="{FF2B5EF4-FFF2-40B4-BE49-F238E27FC236}">
+                <a16:creationId xmlns:a16="http://schemas.microsoft.com/office/drawing/2014/main" id="{F0CC515C-5AE8-C32A-D2AF-AB547E5DF3AF}"/>
+              </a:ext>
+            </a:extLst>
+          </p:cNvPr>
+          <p:cNvSpPr txBox="1">
+            <a:spLocks noChangeArrowheads="1"/>
+          </p:cNvSpPr>
+          <p:nvPr/>
+        </p:nvSpPr>
+        <p:spPr bwMode="auto">
+          <a:xfrm>
+            <a:off x="0" y="1052735"/>
+            <a:ext cx="9180512" cy="338554"/>
+          </a:xfrm>
+          <a:prstGeom prst="rect">
+            <a:avLst/>
+          </a:prstGeom>
+          <a:solidFill>
+            <a:srgbClr val="FFC000"/>
+          </a:solidFill>
+          <a:ln w="9525">
+            <a:noFill/>
+            <a:miter lim="800000"/>
+          </a:ln>
+        </p:spPr>
+        <p:txBody>
+          <a:bodyPr wrap="square">
+            <a:spAutoFit/>
+          </a:bodyPr>
+          <a:lstStyle/>
+          <a:p>
+            <a:pPr algn="ctr"/>
+            <a:r>
+              <a:rPr lang="en-US" sz="1600" b="1" dirty="0">
+                <a:latin typeface="Times New Roman" panose="02020603050405020304" pitchFamily="18" charset="0"/>
+                <a:cs typeface="Times New Roman" panose="02020603050405020304" pitchFamily="18" charset="0"/>
+              </a:rPr>
+              <a:t>Final Presentation </a:t>
+            </a:r>
+            <a:endParaRPr lang="en-IN" sz="1600" b="1" dirty="0">
+              <a:latin typeface="Times New Roman" panose="02020603050405020304" pitchFamily="18" charset="0"/>
+              <a:cs typeface="Times New Roman" panose="02020603050405020304" pitchFamily="18" charset="0"/>
+            </a:endParaRPr>
+          </a:p>
+        </p:txBody>
+      </p:sp>
     </p:spTree>
     <p:extLst>
       <p:ext uri="{BB962C8B-B14F-4D97-AF65-F5344CB8AC3E}">
@@ -7565,6 +8035,941 @@
 </file>
 
 <file path=ppt/slides/slide12.xml><?xml version="1.0" encoding="utf-8"?>
+<p:sld xmlns:a="http://schemas.openxmlformats.org/drawingml/2006/main" xmlns:r="http://schemas.openxmlformats.org/officeDocument/2006/relationships" xmlns:p="http://schemas.openxmlformats.org/presentationml/2006/main">
+  <p:cSld>
+    <p:spTree>
+      <p:nvGrpSpPr>
+        <p:cNvPr id="1" name="">
+          <a:extLst>
+            <a:ext uri="{FF2B5EF4-FFF2-40B4-BE49-F238E27FC236}">
+              <a16:creationId xmlns:a16="http://schemas.microsoft.com/office/drawing/2014/main" id="{2638EBB4-FC21-854D-32A9-7E8F12B4CE88}"/>
+            </a:ext>
+          </a:extLst>
+        </p:cNvPr>
+        <p:cNvGrpSpPr/>
+        <p:nvPr/>
+      </p:nvGrpSpPr>
+      <p:grpSpPr>
+        <a:xfrm>
+          <a:off x="0" y="0"/>
+          <a:ext cx="0" cy="0"/>
+          <a:chOff x="0" y="0"/>
+          <a:chExt cx="0" cy="0"/>
+        </a:xfrm>
+      </p:grpSpPr>
+      <p:sp>
+        <p:nvSpPr>
+          <p:cNvPr id="1048598" name="Rectangle 5">
+            <a:extLst>
+              <a:ext uri="{FF2B5EF4-FFF2-40B4-BE49-F238E27FC236}">
+                <a16:creationId xmlns:a16="http://schemas.microsoft.com/office/drawing/2014/main" id="{9E8BB95B-DA69-6DA8-3B63-B95CE31C3117}"/>
+              </a:ext>
+            </a:extLst>
+          </p:cNvPr>
+          <p:cNvSpPr>
+            <a:spLocks noGrp="1" noChangeArrowheads="1"/>
+          </p:cNvSpPr>
+          <p:nvPr>
+            <p:ph type="ctrTitle"/>
+          </p:nvPr>
+        </p:nvSpPr>
+        <p:spPr>
+          <a:xfrm>
+            <a:off x="1043608" y="160813"/>
+            <a:ext cx="6984776" cy="1035939"/>
+          </a:xfrm>
+          <a:solidFill>
+            <a:schemeClr val="bg1"/>
+          </a:solidFill>
+          <a:effectLst>
+            <a:outerShdw dist="35921" dir="2700000" algn="ctr" rotWithShape="0">
+              <a:schemeClr val="accent1">
+                <a:alpha val="50000"/>
+              </a:schemeClr>
+            </a:outerShdw>
+          </a:effectLst>
+        </p:spPr>
+        <p:txBody>
+          <a:bodyPr>
+            <a:noAutofit/>
+          </a:bodyPr>
+          <a:lstStyle/>
+          <a:p>
+            <a:r>
+              <a:rPr lang="en-US" sz="1600" dirty="0"/>
+              <a:t>Nutan Maharashtra </a:t>
+            </a:r>
+            <a:r>
+              <a:rPr lang="en-US" sz="1600" dirty="0" err="1"/>
+              <a:t>Vidya</a:t>
+            </a:r>
+            <a:r>
+              <a:rPr lang="en-US" sz="1600" dirty="0"/>
+              <a:t> </a:t>
+            </a:r>
+            <a:r>
+              <a:rPr lang="en-US" sz="1600" dirty="0" err="1"/>
+              <a:t>Prasarak</a:t>
+            </a:r>
+            <a:r>
+              <a:rPr lang="en-US" sz="1600" dirty="0"/>
+              <a:t> </a:t>
+            </a:r>
+            <a:r>
+              <a:rPr lang="en-US" sz="1600" dirty="0" err="1"/>
+              <a:t>Mandal’s</a:t>
+            </a:r>
+            <a:r>
+              <a:rPr lang="en-US" sz="1600" dirty="0"/>
+              <a:t> </a:t>
+            </a:r>
+            <a:br>
+              <a:rPr lang="en-US" sz="1600" dirty="0"/>
+            </a:br>
+            <a:r>
+              <a:rPr lang="en-US" sz="1800" dirty="0"/>
+              <a:t> </a:t>
+            </a:r>
+            <a:r>
+              <a:rPr lang="en-US" sz="1800" b="1" dirty="0"/>
+              <a:t>NUTAN COLLEGE OF ENGINEERING AND RESEARCH </a:t>
+            </a:r>
+            <a:br>
+              <a:rPr lang="en-US" sz="1800" dirty="0"/>
+            </a:br>
+            <a:r>
+              <a:rPr lang="en-US" sz="1600" dirty="0"/>
+              <a:t>Under Administrative Support of </a:t>
+            </a:r>
+            <a:r>
+              <a:rPr lang="en-US" sz="1600" dirty="0" err="1"/>
+              <a:t>Pimpri</a:t>
+            </a:r>
+            <a:r>
+              <a:rPr lang="en-US" sz="1600" dirty="0"/>
+              <a:t> </a:t>
+            </a:r>
+            <a:r>
+              <a:rPr lang="en-US" sz="1600" dirty="0" err="1"/>
+              <a:t>Chinchwad</a:t>
+            </a:r>
+            <a:r>
+              <a:rPr lang="en-US" sz="1600" dirty="0"/>
+              <a:t>  Education Trust </a:t>
+            </a:r>
+            <a:br>
+              <a:rPr lang="en-US" sz="1600" dirty="0"/>
+            </a:br>
+            <a:r>
+              <a:rPr lang="en-US" sz="1600" dirty="0"/>
+              <a:t>ISO 21001:2018 EOMS Certified </a:t>
+            </a:r>
+            <a:r>
+              <a:rPr lang="en-US" sz="1200" dirty="0"/>
+              <a:t>	</a:t>
+            </a:r>
+            <a:br>
+              <a:rPr lang="en-US" sz="1200" dirty="0"/>
+            </a:br>
+            <a:endParaRPr lang="en-US" sz="1400" dirty="0"/>
+          </a:p>
+        </p:txBody>
+      </p:sp>
+      <p:pic>
+        <p:nvPicPr>
+          <p:cNvPr id="2097159" name="Picture 6">
+            <a:extLst>
+              <a:ext uri="{FF2B5EF4-FFF2-40B4-BE49-F238E27FC236}">
+                <a16:creationId xmlns:a16="http://schemas.microsoft.com/office/drawing/2014/main" id="{9792C51B-EEA5-03BB-40C6-A3747275AC90}"/>
+              </a:ext>
+            </a:extLst>
+          </p:cNvPr>
+          <p:cNvPicPr>
+            <a:picLocks noChangeAspect="1" noChangeArrowheads="1"/>
+          </p:cNvPicPr>
+          <p:nvPr/>
+        </p:nvPicPr>
+        <p:blipFill>
+          <a:blip r:embed="rId3" cstate="print">
+            <a:extLst>
+              <a:ext uri="{28A0092B-C50C-407E-A947-70E740481C1C}">
+                <a14:useLocalDpi xmlns:a14="http://schemas.microsoft.com/office/drawing/2010/main" val="0"/>
+              </a:ext>
+            </a:extLst>
+          </a:blip>
+          <a:stretch>
+            <a:fillRect/>
+          </a:stretch>
+        </p:blipFill>
+        <p:spPr bwMode="auto">
+          <a:xfrm>
+            <a:off x="467544" y="19232"/>
+            <a:ext cx="1202454" cy="1033504"/>
+          </a:xfrm>
+          <a:prstGeom prst="rect">
+            <a:avLst/>
+          </a:prstGeom>
+          <a:noFill/>
+          <a:ln w="9525">
+            <a:noFill/>
+            <a:miter lim="800000"/>
+            <a:headEnd/>
+            <a:tailEnd/>
+          </a:ln>
+        </p:spPr>
+      </p:pic>
+      <p:sp>
+        <p:nvSpPr>
+          <p:cNvPr id="1048601" name="TextBox 7">
+            <a:extLst>
+              <a:ext uri="{FF2B5EF4-FFF2-40B4-BE49-F238E27FC236}">
+                <a16:creationId xmlns:a16="http://schemas.microsoft.com/office/drawing/2014/main" id="{887FA0D6-230B-15C4-61C4-F316FC49742B}"/>
+              </a:ext>
+            </a:extLst>
+          </p:cNvPr>
+          <p:cNvSpPr txBox="1">
+            <a:spLocks noChangeArrowheads="1"/>
+          </p:cNvSpPr>
+          <p:nvPr/>
+        </p:nvSpPr>
+        <p:spPr bwMode="auto">
+          <a:xfrm>
+            <a:off x="36512" y="1052736"/>
+            <a:ext cx="9144000" cy="338554"/>
+          </a:xfrm>
+          <a:prstGeom prst="rect">
+            <a:avLst/>
+          </a:prstGeom>
+          <a:solidFill>
+            <a:srgbClr val="FFC000"/>
+          </a:solidFill>
+          <a:ln w="9525">
+            <a:noFill/>
+            <a:miter lim="800000"/>
+          </a:ln>
+        </p:spPr>
+        <p:txBody>
+          <a:bodyPr wrap="square">
+            <a:spAutoFit/>
+          </a:bodyPr>
+          <a:lstStyle/>
+          <a:p>
+            <a:pPr algn="ctr"/>
+            <a:r>
+              <a:rPr lang="en-US" sz="1600" b="1" dirty="0">
+                <a:latin typeface="Times New Roman" panose="02020603050405020304" pitchFamily="18" charset="0"/>
+                <a:cs typeface="Times New Roman" panose="02020603050405020304" pitchFamily="18" charset="0"/>
+              </a:rPr>
+              <a:t>Review - IV</a:t>
+            </a:r>
+            <a:endParaRPr lang="en-IN" sz="1600" b="1" dirty="0">
+              <a:latin typeface="Times New Roman" panose="02020603050405020304" pitchFamily="18" charset="0"/>
+              <a:cs typeface="Times New Roman" panose="02020603050405020304" pitchFamily="18" charset="0"/>
+            </a:endParaRPr>
+          </a:p>
+        </p:txBody>
+      </p:sp>
+      <p:sp>
+        <p:nvSpPr>
+          <p:cNvPr id="2" name="Slide Number Placeholder 1">
+            <a:extLst>
+              <a:ext uri="{FF2B5EF4-FFF2-40B4-BE49-F238E27FC236}">
+                <a16:creationId xmlns:a16="http://schemas.microsoft.com/office/drawing/2014/main" id="{9CC67AAC-452D-37B5-D5A5-E871DA8CAC64}"/>
+              </a:ext>
+            </a:extLst>
+          </p:cNvPr>
+          <p:cNvSpPr>
+            <a:spLocks noGrp="1"/>
+          </p:cNvSpPr>
+          <p:nvPr>
+            <p:ph type="sldNum" sz="quarter" idx="12"/>
+          </p:nvPr>
+        </p:nvSpPr>
+        <p:spPr/>
+        <p:txBody>
+          <a:bodyPr/>
+          <a:lstStyle/>
+          <a:p>
+            <a:fld id="{1EC248AB-E565-412B-9D95-9B07D6A4F3F3}" type="slidenum">
+              <a:rPr lang="en-GB" b="1" smtClean="0">
+                <a:solidFill>
+                  <a:schemeClr val="tx1"/>
+                </a:solidFill>
+              </a:rPr>
+              <a:pPr/>
+              <a:t>12</a:t>
+            </a:fld>
+            <a:endParaRPr lang="en-GB" b="1" dirty="0">
+              <a:solidFill>
+                <a:schemeClr val="tx1"/>
+              </a:solidFill>
+            </a:endParaRPr>
+          </a:p>
+        </p:txBody>
+      </p:sp>
+      <p:pic>
+        <p:nvPicPr>
+          <p:cNvPr id="1027" name="Picture 3" descr="C:\Users\admin\Desktop\download.png">
+            <a:extLst>
+              <a:ext uri="{FF2B5EF4-FFF2-40B4-BE49-F238E27FC236}">
+                <a16:creationId xmlns:a16="http://schemas.microsoft.com/office/drawing/2014/main" id="{BD3249F9-333F-53FB-7719-7D4BB5DB3036}"/>
+              </a:ext>
+            </a:extLst>
+          </p:cNvPr>
+          <p:cNvPicPr>
+            <a:picLocks noChangeAspect="1" noChangeArrowheads="1"/>
+          </p:cNvPicPr>
+          <p:nvPr/>
+        </p:nvPicPr>
+        <p:blipFill>
+          <a:blip r:embed="rId4">
+            <a:extLst>
+              <a:ext uri="{28A0092B-C50C-407E-A947-70E740481C1C}">
+                <a14:useLocalDpi xmlns:a14="http://schemas.microsoft.com/office/drawing/2010/main" val="0"/>
+              </a:ext>
+            </a:extLst>
+          </a:blip>
+          <a:srcRect/>
+          <a:stretch>
+            <a:fillRect/>
+          </a:stretch>
+        </p:blipFill>
+        <p:spPr bwMode="auto">
+          <a:xfrm>
+            <a:off x="7452320" y="44624"/>
+            <a:ext cx="1207008" cy="1033505"/>
+          </a:xfrm>
+          <a:prstGeom prst="rect">
+            <a:avLst/>
+          </a:prstGeom>
+          <a:noFill/>
+          <a:extLst>
+            <a:ext uri="{909E8E84-426E-40DD-AFC4-6F175D3DCCD1}">
+              <a14:hiddenFill xmlns:a14="http://schemas.microsoft.com/office/drawing/2010/main">
+                <a:solidFill>
+                  <a:srgbClr val="FFFFFF"/>
+                </a:solidFill>
+              </a14:hiddenFill>
+            </a:ext>
+          </a:extLst>
+        </p:spPr>
+      </p:pic>
+      <p:sp>
+        <p:nvSpPr>
+          <p:cNvPr id="3" name="Rectangle 2">
+            <a:extLst>
+              <a:ext uri="{FF2B5EF4-FFF2-40B4-BE49-F238E27FC236}">
+                <a16:creationId xmlns:a16="http://schemas.microsoft.com/office/drawing/2014/main" id="{9A2B5925-DE6D-F710-5E03-13409929D311}"/>
+              </a:ext>
+            </a:extLst>
+          </p:cNvPr>
+          <p:cNvSpPr/>
+          <p:nvPr/>
+        </p:nvSpPr>
+        <p:spPr>
+          <a:xfrm>
+            <a:off x="59285" y="1582511"/>
+            <a:ext cx="9084715" cy="584775"/>
+          </a:xfrm>
+          <a:prstGeom prst="rect">
+            <a:avLst/>
+          </a:prstGeom>
+        </p:spPr>
+        <p:txBody>
+          <a:bodyPr wrap="square">
+            <a:spAutoFit/>
+          </a:bodyPr>
+          <a:lstStyle/>
+          <a:p>
+            <a:pPr lvl="0" algn="ctr" eaLnBrk="0" fontAlgn="base" hangingPunct="0">
+              <a:spcBef>
+                <a:spcPct val="0"/>
+              </a:spcBef>
+              <a:spcAft>
+                <a:spcPct val="0"/>
+              </a:spcAft>
+            </a:pPr>
+            <a:r>
+              <a:rPr lang="en-US" altLang="en-US" sz="3200" b="1" dirty="0">
+                <a:latin typeface="Times New Roman" panose="02020603050405020304" pitchFamily="18" charset="0"/>
+                <a:cs typeface="Times New Roman" panose="02020603050405020304" pitchFamily="18" charset="0"/>
+              </a:rPr>
+              <a:t>Implementation of Work / Result</a:t>
+            </a:r>
+          </a:p>
+        </p:txBody>
+      </p:sp>
+      <p:pic>
+        <p:nvPicPr>
+          <p:cNvPr id="5" name="Picture 4">
+            <a:extLst>
+              <a:ext uri="{FF2B5EF4-FFF2-40B4-BE49-F238E27FC236}">
+                <a16:creationId xmlns:a16="http://schemas.microsoft.com/office/drawing/2014/main" id="{59F7B0A2-75FB-D05E-D817-84DBB2AB2BE0}"/>
+              </a:ext>
+            </a:extLst>
+          </p:cNvPr>
+          <p:cNvPicPr>
+            <a:picLocks noChangeAspect="1"/>
+          </p:cNvPicPr>
+          <p:nvPr/>
+        </p:nvPicPr>
+        <p:blipFill>
+          <a:blip r:embed="rId5">
+            <a:extLst>
+              <a:ext uri="{28A0092B-C50C-407E-A947-70E740481C1C}">
+                <a14:useLocalDpi xmlns:a14="http://schemas.microsoft.com/office/drawing/2010/main" val="0"/>
+              </a:ext>
+            </a:extLst>
+          </a:blip>
+          <a:stretch>
+            <a:fillRect/>
+          </a:stretch>
+        </p:blipFill>
+        <p:spPr>
+          <a:xfrm>
+            <a:off x="461447" y="2424794"/>
+            <a:ext cx="8388424" cy="3393857"/>
+          </a:xfrm>
+          <a:prstGeom prst="rect">
+            <a:avLst/>
+          </a:prstGeom>
+          <a:ln>
+            <a:solidFill>
+              <a:schemeClr val="tx1"/>
+            </a:solidFill>
+          </a:ln>
+        </p:spPr>
+      </p:pic>
+      <p:sp>
+        <p:nvSpPr>
+          <p:cNvPr id="7" name="TextBox 7">
+            <a:extLst>
+              <a:ext uri="{FF2B5EF4-FFF2-40B4-BE49-F238E27FC236}">
+                <a16:creationId xmlns:a16="http://schemas.microsoft.com/office/drawing/2014/main" id="{63853847-7DEC-2828-6BC2-4978121F4AB2}"/>
+              </a:ext>
+            </a:extLst>
+          </p:cNvPr>
+          <p:cNvSpPr txBox="1">
+            <a:spLocks noChangeArrowheads="1"/>
+          </p:cNvSpPr>
+          <p:nvPr/>
+        </p:nvSpPr>
+        <p:spPr bwMode="auto">
+          <a:xfrm>
+            <a:off x="0" y="1052735"/>
+            <a:ext cx="9180512" cy="338554"/>
+          </a:xfrm>
+          <a:prstGeom prst="rect">
+            <a:avLst/>
+          </a:prstGeom>
+          <a:solidFill>
+            <a:srgbClr val="FFC000"/>
+          </a:solidFill>
+          <a:ln w="9525">
+            <a:noFill/>
+            <a:miter lim="800000"/>
+          </a:ln>
+        </p:spPr>
+        <p:txBody>
+          <a:bodyPr wrap="square">
+            <a:spAutoFit/>
+          </a:bodyPr>
+          <a:lstStyle/>
+          <a:p>
+            <a:pPr algn="ctr"/>
+            <a:r>
+              <a:rPr lang="en-US" sz="1600" b="1" dirty="0">
+                <a:latin typeface="Times New Roman" panose="02020603050405020304" pitchFamily="18" charset="0"/>
+                <a:cs typeface="Times New Roman" panose="02020603050405020304" pitchFamily="18" charset="0"/>
+              </a:rPr>
+              <a:t>Final Presentation </a:t>
+            </a:r>
+            <a:endParaRPr lang="en-IN" sz="1600" b="1" dirty="0">
+              <a:latin typeface="Times New Roman" panose="02020603050405020304" pitchFamily="18" charset="0"/>
+              <a:cs typeface="Times New Roman" panose="02020603050405020304" pitchFamily="18" charset="0"/>
+            </a:endParaRPr>
+          </a:p>
+        </p:txBody>
+      </p:sp>
+    </p:spTree>
+    <p:extLst>
+      <p:ext uri="{BB962C8B-B14F-4D97-AF65-F5344CB8AC3E}">
+        <p14:creationId xmlns:p14="http://schemas.microsoft.com/office/powerpoint/2010/main" val="3260311839"/>
+      </p:ext>
+    </p:extLst>
+  </p:cSld>
+  <p:clrMapOvr>
+    <a:masterClrMapping/>
+  </p:clrMapOvr>
+</p:sld>
+</file>
+
+<file path=ppt/slides/slide13.xml><?xml version="1.0" encoding="utf-8"?>
+<p:sld xmlns:a="http://schemas.openxmlformats.org/drawingml/2006/main" xmlns:r="http://schemas.openxmlformats.org/officeDocument/2006/relationships" xmlns:p="http://schemas.openxmlformats.org/presentationml/2006/main">
+  <p:cSld>
+    <p:spTree>
+      <p:nvGrpSpPr>
+        <p:cNvPr id="1" name="">
+          <a:extLst>
+            <a:ext uri="{FF2B5EF4-FFF2-40B4-BE49-F238E27FC236}">
+              <a16:creationId xmlns:a16="http://schemas.microsoft.com/office/drawing/2014/main" id="{AD8BCF73-65A8-690B-A766-631319BFECFF}"/>
+            </a:ext>
+          </a:extLst>
+        </p:cNvPr>
+        <p:cNvGrpSpPr/>
+        <p:nvPr/>
+      </p:nvGrpSpPr>
+      <p:grpSpPr>
+        <a:xfrm>
+          <a:off x="0" y="0"/>
+          <a:ext cx="0" cy="0"/>
+          <a:chOff x="0" y="0"/>
+          <a:chExt cx="0" cy="0"/>
+        </a:xfrm>
+      </p:grpSpPr>
+      <p:sp>
+        <p:nvSpPr>
+          <p:cNvPr id="1048598" name="Rectangle 5">
+            <a:extLst>
+              <a:ext uri="{FF2B5EF4-FFF2-40B4-BE49-F238E27FC236}">
+                <a16:creationId xmlns:a16="http://schemas.microsoft.com/office/drawing/2014/main" id="{311BB343-F756-8639-0D24-9C2E7D99DCEA}"/>
+              </a:ext>
+            </a:extLst>
+          </p:cNvPr>
+          <p:cNvSpPr>
+            <a:spLocks noGrp="1" noChangeArrowheads="1"/>
+          </p:cNvSpPr>
+          <p:nvPr>
+            <p:ph type="ctrTitle"/>
+          </p:nvPr>
+        </p:nvSpPr>
+        <p:spPr>
+          <a:xfrm>
+            <a:off x="1043608" y="160813"/>
+            <a:ext cx="6984776" cy="1035939"/>
+          </a:xfrm>
+          <a:solidFill>
+            <a:schemeClr val="bg1"/>
+          </a:solidFill>
+          <a:effectLst>
+            <a:outerShdw dist="35921" dir="2700000" algn="ctr" rotWithShape="0">
+              <a:schemeClr val="accent1">
+                <a:alpha val="50000"/>
+              </a:schemeClr>
+            </a:outerShdw>
+          </a:effectLst>
+        </p:spPr>
+        <p:txBody>
+          <a:bodyPr>
+            <a:noAutofit/>
+          </a:bodyPr>
+          <a:lstStyle/>
+          <a:p>
+            <a:r>
+              <a:rPr lang="en-US" sz="1600" dirty="0"/>
+              <a:t>Nutan Maharashtra </a:t>
+            </a:r>
+            <a:r>
+              <a:rPr lang="en-US" sz="1600" dirty="0" err="1"/>
+              <a:t>Vidya</a:t>
+            </a:r>
+            <a:r>
+              <a:rPr lang="en-US" sz="1600" dirty="0"/>
+              <a:t> </a:t>
+            </a:r>
+            <a:r>
+              <a:rPr lang="en-US" sz="1600" dirty="0" err="1"/>
+              <a:t>Prasarak</a:t>
+            </a:r>
+            <a:r>
+              <a:rPr lang="en-US" sz="1600" dirty="0"/>
+              <a:t> </a:t>
+            </a:r>
+            <a:r>
+              <a:rPr lang="en-US" sz="1600" dirty="0" err="1"/>
+              <a:t>Mandal’s</a:t>
+            </a:r>
+            <a:r>
+              <a:rPr lang="en-US" sz="1600" dirty="0"/>
+              <a:t> </a:t>
+            </a:r>
+            <a:br>
+              <a:rPr lang="en-US" sz="1600" dirty="0"/>
+            </a:br>
+            <a:r>
+              <a:rPr lang="en-US" sz="1800" dirty="0"/>
+              <a:t> </a:t>
+            </a:r>
+            <a:r>
+              <a:rPr lang="en-US" sz="1800" b="1" dirty="0"/>
+              <a:t>NUTAN COLLEGE OF ENGINEERING AND RESEARCH </a:t>
+            </a:r>
+            <a:br>
+              <a:rPr lang="en-US" sz="1800" dirty="0"/>
+            </a:br>
+            <a:r>
+              <a:rPr lang="en-US" sz="1600" dirty="0"/>
+              <a:t>Under Administrative Support of </a:t>
+            </a:r>
+            <a:r>
+              <a:rPr lang="en-US" sz="1600" dirty="0" err="1"/>
+              <a:t>Pimpri</a:t>
+            </a:r>
+            <a:r>
+              <a:rPr lang="en-US" sz="1600" dirty="0"/>
+              <a:t> </a:t>
+            </a:r>
+            <a:r>
+              <a:rPr lang="en-US" sz="1600" dirty="0" err="1"/>
+              <a:t>Chinchwad</a:t>
+            </a:r>
+            <a:r>
+              <a:rPr lang="en-US" sz="1600" dirty="0"/>
+              <a:t>  Education Trust </a:t>
+            </a:r>
+            <a:br>
+              <a:rPr lang="en-US" sz="1600" dirty="0"/>
+            </a:br>
+            <a:r>
+              <a:rPr lang="en-US" sz="1600" dirty="0"/>
+              <a:t>ISO 21001:2018 EOMS Certified </a:t>
+            </a:r>
+            <a:r>
+              <a:rPr lang="en-US" sz="1200" dirty="0"/>
+              <a:t>	</a:t>
+            </a:r>
+            <a:br>
+              <a:rPr lang="en-US" sz="1200" dirty="0"/>
+            </a:br>
+            <a:endParaRPr lang="en-US" sz="1400" dirty="0"/>
+          </a:p>
+        </p:txBody>
+      </p:sp>
+      <p:pic>
+        <p:nvPicPr>
+          <p:cNvPr id="2097159" name="Picture 6">
+            <a:extLst>
+              <a:ext uri="{FF2B5EF4-FFF2-40B4-BE49-F238E27FC236}">
+                <a16:creationId xmlns:a16="http://schemas.microsoft.com/office/drawing/2014/main" id="{7040C0DC-9ABD-65A0-DD82-881E3A87BBD9}"/>
+              </a:ext>
+            </a:extLst>
+          </p:cNvPr>
+          <p:cNvPicPr>
+            <a:picLocks noChangeAspect="1" noChangeArrowheads="1"/>
+          </p:cNvPicPr>
+          <p:nvPr/>
+        </p:nvPicPr>
+        <p:blipFill>
+          <a:blip r:embed="rId3" cstate="print">
+            <a:extLst>
+              <a:ext uri="{28A0092B-C50C-407E-A947-70E740481C1C}">
+                <a14:useLocalDpi xmlns:a14="http://schemas.microsoft.com/office/drawing/2010/main" val="0"/>
+              </a:ext>
+            </a:extLst>
+          </a:blip>
+          <a:stretch>
+            <a:fillRect/>
+          </a:stretch>
+        </p:blipFill>
+        <p:spPr bwMode="auto">
+          <a:xfrm>
+            <a:off x="467544" y="19232"/>
+            <a:ext cx="1202454" cy="1033504"/>
+          </a:xfrm>
+          <a:prstGeom prst="rect">
+            <a:avLst/>
+          </a:prstGeom>
+          <a:noFill/>
+          <a:ln w="9525">
+            <a:noFill/>
+            <a:miter lim="800000"/>
+            <a:headEnd/>
+            <a:tailEnd/>
+          </a:ln>
+        </p:spPr>
+      </p:pic>
+      <p:sp>
+        <p:nvSpPr>
+          <p:cNvPr id="1048601" name="TextBox 7">
+            <a:extLst>
+              <a:ext uri="{FF2B5EF4-FFF2-40B4-BE49-F238E27FC236}">
+                <a16:creationId xmlns:a16="http://schemas.microsoft.com/office/drawing/2014/main" id="{555FC6C7-ABB3-395A-19AA-DCFC585732BA}"/>
+              </a:ext>
+            </a:extLst>
+          </p:cNvPr>
+          <p:cNvSpPr txBox="1">
+            <a:spLocks noChangeArrowheads="1"/>
+          </p:cNvSpPr>
+          <p:nvPr/>
+        </p:nvSpPr>
+        <p:spPr bwMode="auto">
+          <a:xfrm>
+            <a:off x="36512" y="1052736"/>
+            <a:ext cx="9144000" cy="338554"/>
+          </a:xfrm>
+          <a:prstGeom prst="rect">
+            <a:avLst/>
+          </a:prstGeom>
+          <a:solidFill>
+            <a:srgbClr val="FFC000"/>
+          </a:solidFill>
+          <a:ln w="9525">
+            <a:noFill/>
+            <a:miter lim="800000"/>
+          </a:ln>
+        </p:spPr>
+        <p:txBody>
+          <a:bodyPr wrap="square">
+            <a:spAutoFit/>
+          </a:bodyPr>
+          <a:lstStyle/>
+          <a:p>
+            <a:pPr algn="ctr"/>
+            <a:r>
+              <a:rPr lang="en-US" sz="1600" b="1" dirty="0">
+                <a:latin typeface="Times New Roman" panose="02020603050405020304" pitchFamily="18" charset="0"/>
+                <a:cs typeface="Times New Roman" panose="02020603050405020304" pitchFamily="18" charset="0"/>
+              </a:rPr>
+              <a:t>Review - IV</a:t>
+            </a:r>
+            <a:endParaRPr lang="en-IN" sz="1600" b="1" dirty="0">
+              <a:latin typeface="Times New Roman" panose="02020603050405020304" pitchFamily="18" charset="0"/>
+              <a:cs typeface="Times New Roman" panose="02020603050405020304" pitchFamily="18" charset="0"/>
+            </a:endParaRPr>
+          </a:p>
+        </p:txBody>
+      </p:sp>
+      <p:sp>
+        <p:nvSpPr>
+          <p:cNvPr id="2" name="Slide Number Placeholder 1">
+            <a:extLst>
+              <a:ext uri="{FF2B5EF4-FFF2-40B4-BE49-F238E27FC236}">
+                <a16:creationId xmlns:a16="http://schemas.microsoft.com/office/drawing/2014/main" id="{47AAFEA6-5298-D1D4-897B-4891DDA82A15}"/>
+              </a:ext>
+            </a:extLst>
+          </p:cNvPr>
+          <p:cNvSpPr>
+            <a:spLocks noGrp="1"/>
+          </p:cNvSpPr>
+          <p:nvPr>
+            <p:ph type="sldNum" sz="quarter" idx="12"/>
+          </p:nvPr>
+        </p:nvSpPr>
+        <p:spPr/>
+        <p:txBody>
+          <a:bodyPr/>
+          <a:lstStyle/>
+          <a:p>
+            <a:fld id="{1EC248AB-E565-412B-9D95-9B07D6A4F3F3}" type="slidenum">
+              <a:rPr lang="en-GB" b="1" smtClean="0">
+                <a:solidFill>
+                  <a:schemeClr val="tx1"/>
+                </a:solidFill>
+              </a:rPr>
+              <a:pPr/>
+              <a:t>13</a:t>
+            </a:fld>
+            <a:endParaRPr lang="en-GB" b="1" dirty="0">
+              <a:solidFill>
+                <a:schemeClr val="tx1"/>
+              </a:solidFill>
+            </a:endParaRPr>
+          </a:p>
+        </p:txBody>
+      </p:sp>
+      <p:pic>
+        <p:nvPicPr>
+          <p:cNvPr id="1027" name="Picture 3" descr="C:\Users\admin\Desktop\download.png">
+            <a:extLst>
+              <a:ext uri="{FF2B5EF4-FFF2-40B4-BE49-F238E27FC236}">
+                <a16:creationId xmlns:a16="http://schemas.microsoft.com/office/drawing/2014/main" id="{0F328E0B-91E0-33BC-1509-2D83CBF964CE}"/>
+              </a:ext>
+            </a:extLst>
+          </p:cNvPr>
+          <p:cNvPicPr>
+            <a:picLocks noChangeAspect="1" noChangeArrowheads="1"/>
+          </p:cNvPicPr>
+          <p:nvPr/>
+        </p:nvPicPr>
+        <p:blipFill>
+          <a:blip r:embed="rId4">
+            <a:extLst>
+              <a:ext uri="{28A0092B-C50C-407E-A947-70E740481C1C}">
+                <a14:useLocalDpi xmlns:a14="http://schemas.microsoft.com/office/drawing/2010/main" val="0"/>
+              </a:ext>
+            </a:extLst>
+          </a:blip>
+          <a:srcRect/>
+          <a:stretch>
+            <a:fillRect/>
+          </a:stretch>
+        </p:blipFill>
+        <p:spPr bwMode="auto">
+          <a:xfrm>
+            <a:off x="7452320" y="44624"/>
+            <a:ext cx="1207008" cy="1033505"/>
+          </a:xfrm>
+          <a:prstGeom prst="rect">
+            <a:avLst/>
+          </a:prstGeom>
+          <a:noFill/>
+          <a:extLst>
+            <a:ext uri="{909E8E84-426E-40DD-AFC4-6F175D3DCCD1}">
+              <a14:hiddenFill xmlns:a14="http://schemas.microsoft.com/office/drawing/2010/main">
+                <a:solidFill>
+                  <a:srgbClr val="FFFFFF"/>
+                </a:solidFill>
+              </a14:hiddenFill>
+            </a:ext>
+          </a:extLst>
+        </p:spPr>
+      </p:pic>
+      <p:sp>
+        <p:nvSpPr>
+          <p:cNvPr id="3" name="Rectangle 2">
+            <a:extLst>
+              <a:ext uri="{FF2B5EF4-FFF2-40B4-BE49-F238E27FC236}">
+                <a16:creationId xmlns:a16="http://schemas.microsoft.com/office/drawing/2014/main" id="{09A843A7-04FB-C20B-F26F-905743866BAE}"/>
+              </a:ext>
+            </a:extLst>
+          </p:cNvPr>
+          <p:cNvSpPr/>
+          <p:nvPr/>
+        </p:nvSpPr>
+        <p:spPr>
+          <a:xfrm>
+            <a:off x="59285" y="1582511"/>
+            <a:ext cx="9084715" cy="584775"/>
+          </a:xfrm>
+          <a:prstGeom prst="rect">
+            <a:avLst/>
+          </a:prstGeom>
+        </p:spPr>
+        <p:txBody>
+          <a:bodyPr wrap="square">
+            <a:spAutoFit/>
+          </a:bodyPr>
+          <a:lstStyle/>
+          <a:p>
+            <a:pPr lvl="0" algn="ctr" eaLnBrk="0" fontAlgn="base" hangingPunct="0">
+              <a:spcBef>
+                <a:spcPct val="0"/>
+              </a:spcBef>
+              <a:spcAft>
+                <a:spcPct val="0"/>
+              </a:spcAft>
+            </a:pPr>
+            <a:r>
+              <a:rPr lang="en-US" altLang="en-US" sz="3200" b="1" dirty="0">
+                <a:latin typeface="Times New Roman" panose="02020603050405020304" pitchFamily="18" charset="0"/>
+                <a:cs typeface="Times New Roman" panose="02020603050405020304" pitchFamily="18" charset="0"/>
+              </a:rPr>
+              <a:t>Implementation of Work / Result</a:t>
+            </a:r>
+          </a:p>
+        </p:txBody>
+      </p:sp>
+      <p:pic>
+        <p:nvPicPr>
+          <p:cNvPr id="6" name="Picture 5">
+            <a:extLst>
+              <a:ext uri="{FF2B5EF4-FFF2-40B4-BE49-F238E27FC236}">
+                <a16:creationId xmlns:a16="http://schemas.microsoft.com/office/drawing/2014/main" id="{F35D71E9-4B4E-8547-EA3C-EEA58E97D4A9}"/>
+              </a:ext>
+            </a:extLst>
+          </p:cNvPr>
+          <p:cNvPicPr>
+            <a:picLocks noChangeAspect="1"/>
+          </p:cNvPicPr>
+          <p:nvPr/>
+        </p:nvPicPr>
+        <p:blipFill>
+          <a:blip r:embed="rId5">
+            <a:extLst>
+              <a:ext uri="{28A0092B-C50C-407E-A947-70E740481C1C}">
+                <a14:useLocalDpi xmlns:a14="http://schemas.microsoft.com/office/drawing/2010/main" val="0"/>
+              </a:ext>
+            </a:extLst>
+          </a:blip>
+          <a:stretch>
+            <a:fillRect/>
+          </a:stretch>
+        </p:blipFill>
+        <p:spPr>
+          <a:xfrm>
+            <a:off x="467544" y="2399402"/>
+            <a:ext cx="7986422" cy="3463840"/>
+          </a:xfrm>
+          <a:prstGeom prst="rect">
+            <a:avLst/>
+          </a:prstGeom>
+        </p:spPr>
+      </p:pic>
+      <p:sp>
+        <p:nvSpPr>
+          <p:cNvPr id="7" name="TextBox 7">
+            <a:extLst>
+              <a:ext uri="{FF2B5EF4-FFF2-40B4-BE49-F238E27FC236}">
+                <a16:creationId xmlns:a16="http://schemas.microsoft.com/office/drawing/2014/main" id="{DE23AC8E-FA94-9EE7-0F29-266D70AE2E09}"/>
+              </a:ext>
+            </a:extLst>
+          </p:cNvPr>
+          <p:cNvSpPr txBox="1">
+            <a:spLocks noChangeArrowheads="1"/>
+          </p:cNvSpPr>
+          <p:nvPr/>
+        </p:nvSpPr>
+        <p:spPr bwMode="auto">
+          <a:xfrm>
+            <a:off x="0" y="1052735"/>
+            <a:ext cx="9180512" cy="338554"/>
+          </a:xfrm>
+          <a:prstGeom prst="rect">
+            <a:avLst/>
+          </a:prstGeom>
+          <a:solidFill>
+            <a:srgbClr val="FFC000"/>
+          </a:solidFill>
+          <a:ln w="9525">
+            <a:noFill/>
+            <a:miter lim="800000"/>
+          </a:ln>
+        </p:spPr>
+        <p:txBody>
+          <a:bodyPr wrap="square">
+            <a:spAutoFit/>
+          </a:bodyPr>
+          <a:lstStyle/>
+          <a:p>
+            <a:pPr algn="ctr"/>
+            <a:r>
+              <a:rPr lang="en-US" sz="1600" b="1" dirty="0">
+                <a:latin typeface="Times New Roman" panose="02020603050405020304" pitchFamily="18" charset="0"/>
+                <a:cs typeface="Times New Roman" panose="02020603050405020304" pitchFamily="18" charset="0"/>
+              </a:rPr>
+              <a:t>Final Presentation </a:t>
+            </a:r>
+            <a:endParaRPr lang="en-IN" sz="1600" b="1" dirty="0">
+              <a:latin typeface="Times New Roman" panose="02020603050405020304" pitchFamily="18" charset="0"/>
+              <a:cs typeface="Times New Roman" panose="02020603050405020304" pitchFamily="18" charset="0"/>
+            </a:endParaRPr>
+          </a:p>
+        </p:txBody>
+      </p:sp>
+    </p:spTree>
+    <p:extLst>
+      <p:ext uri="{BB962C8B-B14F-4D97-AF65-F5344CB8AC3E}">
+        <p14:creationId xmlns:p14="http://schemas.microsoft.com/office/powerpoint/2010/main" val="2953784634"/>
+      </p:ext>
+    </p:extLst>
+  </p:cSld>
+  <p:clrMapOvr>
+    <a:masterClrMapping/>
+  </p:clrMapOvr>
+</p:sld>
+</file>
+
+<file path=ppt/slides/slide14.xml><?xml version="1.0" encoding="utf-8"?>
 <p:sld xmlns:a="http://schemas.openxmlformats.org/drawingml/2006/main" xmlns:r="http://schemas.openxmlformats.org/officeDocument/2006/relationships" xmlns:p="http://schemas.openxmlformats.org/presentationml/2006/main">
   <p:cSld>
     <p:spTree>
@@ -7827,7 +9232,7 @@
                 </a:solidFill>
               </a:rPr>
               <a:pPr/>
-              <a:t>12</a:t>
+              <a:t>14</a:t>
             </a:fld>
             <a:endParaRPr lang="en-GB" b="1" dirty="0">
               <a:solidFill>
@@ -7957,50 +9362,65 @@
         </p:blipFill>
         <p:spPr>
           <a:xfrm>
-            <a:off x="4355976" y="2258412"/>
-            <a:ext cx="4788024" cy="3906892"/>
+            <a:off x="683568" y="2258412"/>
+            <a:ext cx="8003232" cy="3906892"/>
           </a:xfrm>
           <a:prstGeom prst="rect">
             <a:avLst/>
           </a:prstGeom>
         </p:spPr>
       </p:pic>
-      <p:pic>
-        <p:nvPicPr>
-          <p:cNvPr id="9" name="Picture 8">
+      <p:sp>
+        <p:nvSpPr>
+          <p:cNvPr id="4" name="TextBox 7">
             <a:extLst>
               <a:ext uri="{FF2B5EF4-FFF2-40B4-BE49-F238E27FC236}">
-                <a16:creationId xmlns:a16="http://schemas.microsoft.com/office/drawing/2014/main" id="{0A1720EB-6911-5434-047C-F005D26B6BE4}"/>
+                <a16:creationId xmlns:a16="http://schemas.microsoft.com/office/drawing/2014/main" id="{51A5DA57-8BE9-B0E0-B872-5FD3F74F044B}"/>
               </a:ext>
             </a:extLst>
           </p:cNvPr>
-          <p:cNvPicPr>
-            <a:picLocks noChangeAspect="1"/>
-          </p:cNvPicPr>
+          <p:cNvSpPr txBox="1">
+            <a:spLocks noChangeArrowheads="1"/>
+          </p:cNvSpPr>
           <p:nvPr/>
-        </p:nvPicPr>
-        <p:blipFill>
-          <a:blip r:embed="rId6">
-            <a:extLst>
-              <a:ext uri="{28A0092B-C50C-407E-A947-70E740481C1C}">
-                <a14:useLocalDpi xmlns:a14="http://schemas.microsoft.com/office/drawing/2010/main" val="0"/>
-              </a:ext>
-            </a:extLst>
-          </a:blip>
-          <a:stretch>
-            <a:fillRect/>
-          </a:stretch>
-        </p:blipFill>
-        <p:spPr>
+        </p:nvSpPr>
+        <p:spPr bwMode="auto">
           <a:xfrm>
-            <a:off x="107505" y="2210679"/>
-            <a:ext cx="4104456" cy="4026633"/>
+            <a:off x="0" y="1052735"/>
+            <a:ext cx="9180512" cy="338554"/>
           </a:xfrm>
           <a:prstGeom prst="rect">
             <a:avLst/>
           </a:prstGeom>
+          <a:solidFill>
+            <a:srgbClr val="FFC000"/>
+          </a:solidFill>
+          <a:ln w="9525">
+            <a:noFill/>
+            <a:miter lim="800000"/>
+          </a:ln>
         </p:spPr>
-      </p:pic>
+        <p:txBody>
+          <a:bodyPr wrap="square">
+            <a:spAutoFit/>
+          </a:bodyPr>
+          <a:lstStyle/>
+          <a:p>
+            <a:pPr algn="ctr"/>
+            <a:r>
+              <a:rPr lang="en-US" sz="1600" b="1" dirty="0">
+                <a:latin typeface="Times New Roman" panose="02020603050405020304" pitchFamily="18" charset="0"/>
+                <a:cs typeface="Times New Roman" panose="02020603050405020304" pitchFamily="18" charset="0"/>
+              </a:rPr>
+              <a:t>Final Presentation </a:t>
+            </a:r>
+            <a:endParaRPr lang="en-IN" sz="1600" b="1" dirty="0">
+              <a:latin typeface="Times New Roman" panose="02020603050405020304" pitchFamily="18" charset="0"/>
+              <a:cs typeface="Times New Roman" panose="02020603050405020304" pitchFamily="18" charset="0"/>
+            </a:endParaRPr>
+          </a:p>
+        </p:txBody>
+      </p:sp>
     </p:spTree>
     <p:extLst>
       <p:ext uri="{BB962C8B-B14F-4D97-AF65-F5344CB8AC3E}">
@@ -8014,7 +9434,7 @@
 </p:sld>
 </file>
 
-<file path=ppt/slides/slide13.xml><?xml version="1.0" encoding="utf-8"?>
+<file path=ppt/slides/slide15.xml><?xml version="1.0" encoding="utf-8"?>
 <p:sld xmlns:a="http://schemas.openxmlformats.org/drawingml/2006/main" xmlns:r="http://schemas.openxmlformats.org/officeDocument/2006/relationships" xmlns:p="http://schemas.openxmlformats.org/presentationml/2006/main">
   <p:cSld>
     <p:spTree>
@@ -8277,7 +9697,7 @@
                 </a:solidFill>
               </a:rPr>
               <a:pPr/>
-              <a:t>13</a:t>
+              <a:t>15</a:t>
             </a:fld>
             <a:endParaRPr lang="en-GB" b="1" dirty="0">
               <a:solidFill>
@@ -8336,44 +9756,6 @@
       </p:pic>
       <p:sp>
         <p:nvSpPr>
-          <p:cNvPr id="3" name="Rectangle 2">
-            <a:extLst>
-              <a:ext uri="{FF2B5EF4-FFF2-40B4-BE49-F238E27FC236}">
-                <a16:creationId xmlns:a16="http://schemas.microsoft.com/office/drawing/2014/main" id="{CF91F948-9D4F-DBFC-7A3D-D4B513A0E898}"/>
-              </a:ext>
-            </a:extLst>
-          </p:cNvPr>
-          <p:cNvSpPr/>
-          <p:nvPr/>
-        </p:nvSpPr>
-        <p:spPr>
-          <a:xfrm>
-            <a:off x="59285" y="1582511"/>
-            <a:ext cx="9084715" cy="584775"/>
-          </a:xfrm>
-          <a:prstGeom prst="rect">
-            <a:avLst/>
-          </a:prstGeom>
-        </p:spPr>
-        <p:txBody>
-          <a:bodyPr wrap="square">
-            <a:spAutoFit/>
-          </a:bodyPr>
-          <a:lstStyle/>
-          <a:p>
-            <a:pPr algn="ctr">
-              <a:buNone/>
-            </a:pPr>
-            <a:r>
-              <a:rPr lang="en-US" sz="3200" b="1" dirty="0"/>
-              <a:t>Conclusion </a:t>
-            </a:r>
-            <a:endParaRPr lang="en-US" sz="3200" dirty="0"/>
-          </a:p>
-        </p:txBody>
-      </p:sp>
-      <p:sp>
-        <p:nvSpPr>
           <p:cNvPr id="6" name="TextBox 5">
             <a:extLst>
               <a:ext uri="{FF2B5EF4-FFF2-40B4-BE49-F238E27FC236}">
@@ -8386,8 +9768,8 @@
         </p:nvSpPr>
         <p:spPr>
           <a:xfrm>
-            <a:off x="324036" y="2767280"/>
-            <a:ext cx="8568952" cy="1938992"/>
+            <a:off x="324036" y="1556792"/>
+            <a:ext cx="8568952" cy="5324535"/>
           </a:xfrm>
           <a:prstGeom prst="rect">
             <a:avLst/>
@@ -8400,24 +9782,211 @@
           </a:bodyPr>
           <a:lstStyle/>
           <a:p>
-            <a:pPr marL="285750" indent="-285750" algn="just">
+            <a:r>
+              <a:rPr lang="en-IN" sz="2000" b="1" dirty="0"/>
+              <a:t>Title: Database Design (</a:t>
+            </a:r>
+            <a:r>
+              <a:rPr lang="en-IN" sz="2000" b="1" dirty="0" err="1"/>
+              <a:t>Supabase</a:t>
+            </a:r>
+            <a:r>
+              <a:rPr lang="en-IN" sz="2000" b="1" dirty="0"/>
+              <a:t> PostgreSQL)</a:t>
+            </a:r>
+          </a:p>
+          <a:p>
+            <a:r>
+              <a:rPr lang="en-IN" sz="2000" b="1" dirty="0"/>
+              <a:t>Table: -</a:t>
+            </a:r>
+          </a:p>
+          <a:p>
+            <a:endParaRPr lang="en-IN" sz="2000" dirty="0"/>
+          </a:p>
+          <a:p>
+            <a:endParaRPr lang="en-IN" sz="2000" dirty="0"/>
+          </a:p>
+          <a:p>
+            <a:endParaRPr lang="en-IN" sz="2000" dirty="0"/>
+          </a:p>
+          <a:p>
+            <a:endParaRPr lang="en-IN" sz="2000" dirty="0"/>
+          </a:p>
+          <a:p>
+            <a:endParaRPr lang="en-IN" sz="2000" dirty="0"/>
+          </a:p>
+          <a:p>
+            <a:endParaRPr lang="en-IN" sz="2000" dirty="0"/>
+          </a:p>
+          <a:p>
+            <a:endParaRPr lang="en-IN" sz="2000" dirty="0"/>
+          </a:p>
+          <a:p>
+            <a:endParaRPr lang="en-IN" sz="2000" dirty="0"/>
+          </a:p>
+          <a:p>
+            <a:endParaRPr lang="en-IN" sz="2000" dirty="0"/>
+          </a:p>
+          <a:p>
+            <a:r>
+              <a:rPr lang="en-IN" sz="2000" b="1" dirty="0"/>
+              <a:t>Security Features:</a:t>
+            </a:r>
+          </a:p>
+          <a:p>
+            <a:pPr marL="342900" indent="-342900">
               <a:buFont typeface="Arial" panose="020B0604020202020204" pitchFamily="34" charset="0"/>
               <a:buChar char="•"/>
             </a:pPr>
             <a:r>
-              <a:rPr lang="en-US" sz="2000" dirty="0"/>
-              <a:t>We successfully engineered a production-ready Legal AI platform capable of parsing unstructured PDFs, dynamically updating historical laws (IPC to BNS), and predicting appellate outcomes with 85.2% accuracy.</a:t>
-            </a:r>
-          </a:p>
-          <a:p>
-            <a:pPr marL="285750" indent="-285750" algn="just">
+              <a:rPr lang="en-IN" sz="2000" dirty="0"/>
+              <a:t>Row Level Security (RLS) enabled on all tables</a:t>
+            </a:r>
+          </a:p>
+          <a:p>
+            <a:pPr marL="342900" indent="-342900">
               <a:buFont typeface="Arial" panose="020B0604020202020204" pitchFamily="34" charset="0"/>
               <a:buChar char="•"/>
             </a:pPr>
             <a:r>
-              <a:rPr lang="en-US" sz="2000" dirty="0"/>
-              <a:t>By integrating NER-filtered Explainable AI (SHAP) and deploying it on a secure cloud architecture, we transformed a theoretical deep learning model into a practical, highly transparent decision-support tool for Indian lawyers.</a:t>
-            </a:r>
+              <a:rPr lang="en-IN" sz="2000" dirty="0"/>
+              <a:t>Auto-profile creation via PostgreSQL trigger on user signup</a:t>
+            </a:r>
+          </a:p>
+          <a:p>
+            <a:pPr marL="342900" indent="-342900">
+              <a:buFont typeface="Arial" panose="020B0604020202020204" pitchFamily="34" charset="0"/>
+              <a:buChar char="•"/>
+            </a:pPr>
+            <a:r>
+              <a:rPr lang="en-IN" sz="2000" dirty="0"/>
+              <a:t>Performance indexes on </a:t>
+            </a:r>
+            <a:r>
+              <a:rPr lang="en-IN" sz="2000" dirty="0" err="1"/>
+              <a:t>user_email</a:t>
+            </a:r>
+            <a:r>
+              <a:rPr lang="en-IN" sz="2000" dirty="0"/>
+              <a:t> and </a:t>
+            </a:r>
+            <a:r>
+              <a:rPr lang="en-IN" sz="2000" dirty="0" err="1"/>
+              <a:t>case_category</a:t>
+            </a:r>
+            <a:endParaRPr lang="en-IN" sz="2000" dirty="0"/>
+          </a:p>
+          <a:p>
+            <a:pPr marL="342900" indent="-342900">
+              <a:buFont typeface="Arial" panose="020B0604020202020204" pitchFamily="34" charset="0"/>
+              <a:buChar char="•"/>
+            </a:pPr>
+            <a:r>
+              <a:rPr lang="en-IN" sz="2000" dirty="0" err="1"/>
+              <a:t>Supabase</a:t>
+            </a:r>
+            <a:r>
+              <a:rPr lang="en-IN" sz="2000" dirty="0"/>
+              <a:t> Auth for encrypted authentication</a:t>
+            </a:r>
+          </a:p>
+          <a:p>
+            <a:pPr marL="342900" indent="-342900">
+              <a:buFont typeface="Arial" panose="020B0604020202020204" pitchFamily="34" charset="0"/>
+              <a:buChar char="•"/>
+            </a:pPr>
+            <a:r>
+              <a:rPr lang="en-IN" sz="2000" dirty="0"/>
+              <a:t>Role Based Access Control</a:t>
+            </a:r>
+          </a:p>
+        </p:txBody>
+      </p:sp>
+      <p:pic>
+        <p:nvPicPr>
+          <p:cNvPr id="10" name="Picture 9">
+            <a:extLst>
+              <a:ext uri="{FF2B5EF4-FFF2-40B4-BE49-F238E27FC236}">
+                <a16:creationId xmlns:a16="http://schemas.microsoft.com/office/drawing/2014/main" id="{BD9A444D-412B-DB45-6945-68F1218C33EA}"/>
+              </a:ext>
+            </a:extLst>
+          </p:cNvPr>
+          <p:cNvPicPr>
+            <a:picLocks noChangeAspect="1"/>
+          </p:cNvPicPr>
+          <p:nvPr/>
+        </p:nvPicPr>
+        <p:blipFill>
+          <a:blip r:embed="rId5">
+            <a:extLst>
+              <a:ext uri="{28A0092B-C50C-407E-A947-70E740481C1C}">
+                <a14:useLocalDpi xmlns:a14="http://schemas.microsoft.com/office/drawing/2010/main" val="0"/>
+              </a:ext>
+            </a:extLst>
+          </a:blip>
+          <a:stretch>
+            <a:fillRect/>
+          </a:stretch>
+        </p:blipFill>
+        <p:spPr>
+          <a:xfrm>
+            <a:off x="251012" y="2322697"/>
+            <a:ext cx="8784948" cy="2402447"/>
+          </a:xfrm>
+          <a:prstGeom prst="rect">
+            <a:avLst/>
+          </a:prstGeom>
+        </p:spPr>
+      </p:pic>
+      <p:sp>
+        <p:nvSpPr>
+          <p:cNvPr id="11" name="TextBox 7">
+            <a:extLst>
+              <a:ext uri="{FF2B5EF4-FFF2-40B4-BE49-F238E27FC236}">
+                <a16:creationId xmlns:a16="http://schemas.microsoft.com/office/drawing/2014/main" id="{6FC64CDE-FF4D-0EDC-7628-2F75866B084C}"/>
+              </a:ext>
+            </a:extLst>
+          </p:cNvPr>
+          <p:cNvSpPr txBox="1">
+            <a:spLocks noChangeArrowheads="1"/>
+          </p:cNvSpPr>
+          <p:nvPr/>
+        </p:nvSpPr>
+        <p:spPr bwMode="auto">
+          <a:xfrm>
+            <a:off x="0" y="1052735"/>
+            <a:ext cx="9180512" cy="338554"/>
+          </a:xfrm>
+          <a:prstGeom prst="rect">
+            <a:avLst/>
+          </a:prstGeom>
+          <a:solidFill>
+            <a:srgbClr val="FFC000"/>
+          </a:solidFill>
+          <a:ln w="9525">
+            <a:noFill/>
+            <a:miter lim="800000"/>
+          </a:ln>
+        </p:spPr>
+        <p:txBody>
+          <a:bodyPr wrap="square">
+            <a:spAutoFit/>
+          </a:bodyPr>
+          <a:lstStyle/>
+          <a:p>
+            <a:pPr algn="ctr"/>
+            <a:r>
+              <a:rPr lang="en-US" sz="1600" b="1" dirty="0">
+                <a:latin typeface="Times New Roman" panose="02020603050405020304" pitchFamily="18" charset="0"/>
+                <a:cs typeface="Times New Roman" panose="02020603050405020304" pitchFamily="18" charset="0"/>
+              </a:rPr>
+              <a:t>Final Presentation </a:t>
+            </a:r>
+            <a:endParaRPr lang="en-IN" sz="1600" b="1" dirty="0">
+              <a:latin typeface="Times New Roman" panose="02020603050405020304" pitchFamily="18" charset="0"/>
+              <a:cs typeface="Times New Roman" panose="02020603050405020304" pitchFamily="18" charset="0"/>
+            </a:endParaRPr>
           </a:p>
         </p:txBody>
       </p:sp>
@@ -8434,7 +10003,560 @@
 </p:sld>
 </file>
 
-<file path=ppt/slides/slide14.xml><?xml version="1.0" encoding="utf-8"?>
+<file path=ppt/slides/slide16.xml><?xml version="1.0" encoding="utf-8"?>
+<p:sld xmlns:a="http://schemas.openxmlformats.org/drawingml/2006/main" xmlns:r="http://schemas.openxmlformats.org/officeDocument/2006/relationships" xmlns:p="http://schemas.openxmlformats.org/presentationml/2006/main">
+  <p:cSld>
+    <p:spTree>
+      <p:nvGrpSpPr>
+        <p:cNvPr id="1" name="">
+          <a:extLst>
+            <a:ext uri="{FF2B5EF4-FFF2-40B4-BE49-F238E27FC236}">
+              <a16:creationId xmlns:a16="http://schemas.microsoft.com/office/drawing/2014/main" id="{20A68DA4-6C6C-1198-3ED7-66D80A7E3780}"/>
+            </a:ext>
+          </a:extLst>
+        </p:cNvPr>
+        <p:cNvGrpSpPr/>
+        <p:nvPr/>
+      </p:nvGrpSpPr>
+      <p:grpSpPr>
+        <a:xfrm>
+          <a:off x="0" y="0"/>
+          <a:ext cx="0" cy="0"/>
+          <a:chOff x="0" y="0"/>
+          <a:chExt cx="0" cy="0"/>
+        </a:xfrm>
+      </p:grpSpPr>
+      <p:sp>
+        <p:nvSpPr>
+          <p:cNvPr id="1048598" name="Rectangle 5">
+            <a:extLst>
+              <a:ext uri="{FF2B5EF4-FFF2-40B4-BE49-F238E27FC236}">
+                <a16:creationId xmlns:a16="http://schemas.microsoft.com/office/drawing/2014/main" id="{E44F2677-732A-23E5-B7E3-8B70B8D60DFD}"/>
+              </a:ext>
+            </a:extLst>
+          </p:cNvPr>
+          <p:cNvSpPr>
+            <a:spLocks noGrp="1" noChangeArrowheads="1"/>
+          </p:cNvSpPr>
+          <p:nvPr>
+            <p:ph type="ctrTitle"/>
+          </p:nvPr>
+        </p:nvSpPr>
+        <p:spPr>
+          <a:xfrm>
+            <a:off x="1043608" y="160813"/>
+            <a:ext cx="6984776" cy="1035939"/>
+          </a:xfrm>
+          <a:solidFill>
+            <a:schemeClr val="bg1"/>
+          </a:solidFill>
+          <a:effectLst>
+            <a:outerShdw dist="35921" dir="2700000" algn="ctr" rotWithShape="0">
+              <a:schemeClr val="accent1">
+                <a:alpha val="50000"/>
+              </a:schemeClr>
+            </a:outerShdw>
+          </a:effectLst>
+        </p:spPr>
+        <p:txBody>
+          <a:bodyPr>
+            <a:noAutofit/>
+          </a:bodyPr>
+          <a:lstStyle/>
+          <a:p>
+            <a:r>
+              <a:rPr lang="en-US" sz="1600" dirty="0"/>
+              <a:t>Nutan Maharashtra </a:t>
+            </a:r>
+            <a:r>
+              <a:rPr lang="en-US" sz="1600" dirty="0" err="1"/>
+              <a:t>Vidya</a:t>
+            </a:r>
+            <a:r>
+              <a:rPr lang="en-US" sz="1600" dirty="0"/>
+              <a:t> </a:t>
+            </a:r>
+            <a:r>
+              <a:rPr lang="en-US" sz="1600" dirty="0" err="1"/>
+              <a:t>Prasarak</a:t>
+            </a:r>
+            <a:r>
+              <a:rPr lang="en-US" sz="1600" dirty="0"/>
+              <a:t> </a:t>
+            </a:r>
+            <a:r>
+              <a:rPr lang="en-US" sz="1600" dirty="0" err="1"/>
+              <a:t>Mandal’s</a:t>
+            </a:r>
+            <a:r>
+              <a:rPr lang="en-US" sz="1600" dirty="0"/>
+              <a:t> </a:t>
+            </a:r>
+            <a:br>
+              <a:rPr lang="en-US" sz="1600" dirty="0"/>
+            </a:br>
+            <a:r>
+              <a:rPr lang="en-US" sz="1800" dirty="0"/>
+              <a:t> </a:t>
+            </a:r>
+            <a:r>
+              <a:rPr lang="en-US" sz="1800" b="1" dirty="0"/>
+              <a:t>NUTAN COLLEGE OF ENGINEERING AND RESEARCH </a:t>
+            </a:r>
+            <a:br>
+              <a:rPr lang="en-US" sz="1800" dirty="0"/>
+            </a:br>
+            <a:r>
+              <a:rPr lang="en-US" sz="1600" dirty="0"/>
+              <a:t>Under Administrative Support of </a:t>
+            </a:r>
+            <a:r>
+              <a:rPr lang="en-US" sz="1600" dirty="0" err="1"/>
+              <a:t>Pimpri</a:t>
+            </a:r>
+            <a:r>
+              <a:rPr lang="en-US" sz="1600" dirty="0"/>
+              <a:t> </a:t>
+            </a:r>
+            <a:r>
+              <a:rPr lang="en-US" sz="1600" dirty="0" err="1"/>
+              <a:t>Chinchwad</a:t>
+            </a:r>
+            <a:r>
+              <a:rPr lang="en-US" sz="1600" dirty="0"/>
+              <a:t>  Education Trust </a:t>
+            </a:r>
+            <a:br>
+              <a:rPr lang="en-US" sz="1600" dirty="0"/>
+            </a:br>
+            <a:r>
+              <a:rPr lang="en-US" sz="1600" dirty="0"/>
+              <a:t>ISO 21001:2018 EOMS Certified </a:t>
+            </a:r>
+            <a:r>
+              <a:rPr lang="en-US" sz="1200" dirty="0"/>
+              <a:t>	</a:t>
+            </a:r>
+            <a:br>
+              <a:rPr lang="en-US" sz="1200" dirty="0"/>
+            </a:br>
+            <a:endParaRPr lang="en-US" sz="1400" dirty="0"/>
+          </a:p>
+        </p:txBody>
+      </p:sp>
+      <p:pic>
+        <p:nvPicPr>
+          <p:cNvPr id="2097159" name="Picture 6">
+            <a:extLst>
+              <a:ext uri="{FF2B5EF4-FFF2-40B4-BE49-F238E27FC236}">
+                <a16:creationId xmlns:a16="http://schemas.microsoft.com/office/drawing/2014/main" id="{F4F328D4-D97A-2F8C-DFA7-98D8B704485D}"/>
+              </a:ext>
+            </a:extLst>
+          </p:cNvPr>
+          <p:cNvPicPr>
+            <a:picLocks noChangeAspect="1" noChangeArrowheads="1"/>
+          </p:cNvPicPr>
+          <p:nvPr/>
+        </p:nvPicPr>
+        <p:blipFill>
+          <a:blip r:embed="rId3" cstate="print">
+            <a:extLst>
+              <a:ext uri="{28A0092B-C50C-407E-A947-70E740481C1C}">
+                <a14:useLocalDpi xmlns:a14="http://schemas.microsoft.com/office/drawing/2010/main" val="0"/>
+              </a:ext>
+            </a:extLst>
+          </a:blip>
+          <a:stretch>
+            <a:fillRect/>
+          </a:stretch>
+        </p:blipFill>
+        <p:spPr bwMode="auto">
+          <a:xfrm>
+            <a:off x="467544" y="19232"/>
+            <a:ext cx="1202454" cy="1033504"/>
+          </a:xfrm>
+          <a:prstGeom prst="rect">
+            <a:avLst/>
+          </a:prstGeom>
+          <a:noFill/>
+          <a:ln w="9525">
+            <a:noFill/>
+            <a:miter lim="800000"/>
+            <a:headEnd/>
+            <a:tailEnd/>
+          </a:ln>
+        </p:spPr>
+      </p:pic>
+      <p:sp>
+        <p:nvSpPr>
+          <p:cNvPr id="1048601" name="TextBox 7">
+            <a:extLst>
+              <a:ext uri="{FF2B5EF4-FFF2-40B4-BE49-F238E27FC236}">
+                <a16:creationId xmlns:a16="http://schemas.microsoft.com/office/drawing/2014/main" id="{BB146FB4-316F-9EDE-3238-15CB092ADDF8}"/>
+              </a:ext>
+            </a:extLst>
+          </p:cNvPr>
+          <p:cNvSpPr txBox="1">
+            <a:spLocks noChangeArrowheads="1"/>
+          </p:cNvSpPr>
+          <p:nvPr/>
+        </p:nvSpPr>
+        <p:spPr bwMode="auto">
+          <a:xfrm>
+            <a:off x="36512" y="1052736"/>
+            <a:ext cx="9144000" cy="338554"/>
+          </a:xfrm>
+          <a:prstGeom prst="rect">
+            <a:avLst/>
+          </a:prstGeom>
+          <a:solidFill>
+            <a:srgbClr val="FFC000"/>
+          </a:solidFill>
+          <a:ln w="9525">
+            <a:noFill/>
+            <a:miter lim="800000"/>
+          </a:ln>
+        </p:spPr>
+        <p:txBody>
+          <a:bodyPr wrap="square">
+            <a:spAutoFit/>
+          </a:bodyPr>
+          <a:lstStyle/>
+          <a:p>
+            <a:pPr algn="ctr"/>
+            <a:r>
+              <a:rPr lang="en-US" sz="1600" b="1" dirty="0">
+                <a:latin typeface="Times New Roman" panose="02020603050405020304" pitchFamily="18" charset="0"/>
+                <a:cs typeface="Times New Roman" panose="02020603050405020304" pitchFamily="18" charset="0"/>
+              </a:rPr>
+              <a:t>Review - IV</a:t>
+            </a:r>
+            <a:endParaRPr lang="en-IN" sz="1600" b="1" dirty="0">
+              <a:latin typeface="Times New Roman" panose="02020603050405020304" pitchFamily="18" charset="0"/>
+              <a:cs typeface="Times New Roman" panose="02020603050405020304" pitchFamily="18" charset="0"/>
+            </a:endParaRPr>
+          </a:p>
+        </p:txBody>
+      </p:sp>
+      <p:sp>
+        <p:nvSpPr>
+          <p:cNvPr id="2" name="Slide Number Placeholder 1">
+            <a:extLst>
+              <a:ext uri="{FF2B5EF4-FFF2-40B4-BE49-F238E27FC236}">
+                <a16:creationId xmlns:a16="http://schemas.microsoft.com/office/drawing/2014/main" id="{826AAA59-D76B-1F03-76A1-0F3F8F2AB6FD}"/>
+              </a:ext>
+            </a:extLst>
+          </p:cNvPr>
+          <p:cNvSpPr>
+            <a:spLocks noGrp="1"/>
+          </p:cNvSpPr>
+          <p:nvPr>
+            <p:ph type="sldNum" sz="quarter" idx="12"/>
+          </p:nvPr>
+        </p:nvSpPr>
+        <p:spPr/>
+        <p:txBody>
+          <a:bodyPr/>
+          <a:lstStyle/>
+          <a:p>
+            <a:fld id="{1EC248AB-E565-412B-9D95-9B07D6A4F3F3}" type="slidenum">
+              <a:rPr lang="en-GB" b="1" smtClean="0">
+                <a:solidFill>
+                  <a:schemeClr val="tx1"/>
+                </a:solidFill>
+              </a:rPr>
+              <a:pPr/>
+              <a:t>16</a:t>
+            </a:fld>
+            <a:endParaRPr lang="en-GB" b="1" dirty="0">
+              <a:solidFill>
+                <a:schemeClr val="tx1"/>
+              </a:solidFill>
+            </a:endParaRPr>
+          </a:p>
+        </p:txBody>
+      </p:sp>
+      <p:pic>
+        <p:nvPicPr>
+          <p:cNvPr id="1027" name="Picture 3" descr="C:\Users\admin\Desktop\download.png">
+            <a:extLst>
+              <a:ext uri="{FF2B5EF4-FFF2-40B4-BE49-F238E27FC236}">
+                <a16:creationId xmlns:a16="http://schemas.microsoft.com/office/drawing/2014/main" id="{8BA5D5ED-66A2-09A7-F67D-3CE222624017}"/>
+              </a:ext>
+            </a:extLst>
+          </p:cNvPr>
+          <p:cNvPicPr>
+            <a:picLocks noChangeAspect="1" noChangeArrowheads="1"/>
+          </p:cNvPicPr>
+          <p:nvPr/>
+        </p:nvPicPr>
+        <p:blipFill>
+          <a:blip r:embed="rId4">
+            <a:extLst>
+              <a:ext uri="{28A0092B-C50C-407E-A947-70E740481C1C}">
+                <a14:useLocalDpi xmlns:a14="http://schemas.microsoft.com/office/drawing/2010/main" val="0"/>
+              </a:ext>
+            </a:extLst>
+          </a:blip>
+          <a:srcRect/>
+          <a:stretch>
+            <a:fillRect/>
+          </a:stretch>
+        </p:blipFill>
+        <p:spPr bwMode="auto">
+          <a:xfrm>
+            <a:off x="7452320" y="44624"/>
+            <a:ext cx="1207008" cy="1033505"/>
+          </a:xfrm>
+          <a:prstGeom prst="rect">
+            <a:avLst/>
+          </a:prstGeom>
+          <a:noFill/>
+          <a:extLst>
+            <a:ext uri="{909E8E84-426E-40DD-AFC4-6F175D3DCCD1}">
+              <a14:hiddenFill xmlns:a14="http://schemas.microsoft.com/office/drawing/2010/main">
+                <a:solidFill>
+                  <a:srgbClr val="FFFFFF"/>
+                </a:solidFill>
+              </a14:hiddenFill>
+            </a:ext>
+          </a:extLst>
+        </p:spPr>
+      </p:pic>
+      <p:sp>
+        <p:nvSpPr>
+          <p:cNvPr id="3" name="Rectangle 2">
+            <a:extLst>
+              <a:ext uri="{FF2B5EF4-FFF2-40B4-BE49-F238E27FC236}">
+                <a16:creationId xmlns:a16="http://schemas.microsoft.com/office/drawing/2014/main" id="{5FEDBF33-12FC-540D-80A9-BE8CECB97086}"/>
+              </a:ext>
+            </a:extLst>
+          </p:cNvPr>
+          <p:cNvSpPr/>
+          <p:nvPr/>
+        </p:nvSpPr>
+        <p:spPr>
+          <a:xfrm>
+            <a:off x="59285" y="1582511"/>
+            <a:ext cx="9084715" cy="584775"/>
+          </a:xfrm>
+          <a:prstGeom prst="rect">
+            <a:avLst/>
+          </a:prstGeom>
+        </p:spPr>
+        <p:txBody>
+          <a:bodyPr wrap="square">
+            <a:spAutoFit/>
+          </a:bodyPr>
+          <a:lstStyle/>
+          <a:p>
+            <a:pPr algn="ctr">
+              <a:buNone/>
+            </a:pPr>
+            <a:r>
+              <a:rPr lang="en-US" sz="3200" b="1" dirty="0"/>
+              <a:t>Conclusion </a:t>
+            </a:r>
+            <a:endParaRPr lang="en-US" sz="3200" dirty="0"/>
+          </a:p>
+        </p:txBody>
+      </p:sp>
+      <p:sp>
+        <p:nvSpPr>
+          <p:cNvPr id="6" name="TextBox 5">
+            <a:extLst>
+              <a:ext uri="{FF2B5EF4-FFF2-40B4-BE49-F238E27FC236}">
+                <a16:creationId xmlns:a16="http://schemas.microsoft.com/office/drawing/2014/main" id="{9988CB8D-0424-D77A-DA3C-79D78100937B}"/>
+              </a:ext>
+            </a:extLst>
+          </p:cNvPr>
+          <p:cNvSpPr txBox="1"/>
+          <p:nvPr/>
+        </p:nvSpPr>
+        <p:spPr>
+          <a:xfrm>
+            <a:off x="324036" y="2339002"/>
+            <a:ext cx="8568952" cy="3970318"/>
+          </a:xfrm>
+          <a:prstGeom prst="rect">
+            <a:avLst/>
+          </a:prstGeom>
+          <a:noFill/>
+        </p:spPr>
+        <p:txBody>
+          <a:bodyPr wrap="square">
+            <a:spAutoFit/>
+          </a:bodyPr>
+          <a:lstStyle/>
+          <a:p>
+            <a:pPr marL="285750" indent="-285750">
+              <a:buFont typeface="Arial" panose="020B0604020202020204" pitchFamily="34" charset="0"/>
+              <a:buChar char="•"/>
+            </a:pPr>
+            <a:r>
+              <a:rPr lang="en-IN" dirty="0"/>
+              <a:t>We successfully engineered a </a:t>
+            </a:r>
+            <a:r>
+              <a:rPr lang="en-IN" b="1" dirty="0"/>
+              <a:t>production-ready Legal AI platform</a:t>
+            </a:r>
+            <a:r>
+              <a:rPr lang="en-IN" dirty="0"/>
+              <a:t> that parses unstructured court judgment PDFs, preprocesses them through a custom NLP pipeline, and predicts appellate outcomes with </a:t>
+            </a:r>
+            <a:r>
+              <a:rPr lang="en-IN" b="1" dirty="0"/>
+              <a:t>85.2% accuracy</a:t>
+            </a:r>
+            <a:r>
+              <a:rPr lang="en-IN" dirty="0"/>
+              <a:t> using fine-tuned InLegalBERT.</a:t>
+            </a:r>
+          </a:p>
+          <a:p>
+            <a:pPr marL="285750" indent="-285750">
+              <a:buFont typeface="Arial" panose="020B0604020202020204" pitchFamily="34" charset="0"/>
+              <a:buChar char="•"/>
+            </a:pPr>
+            <a:r>
+              <a:rPr lang="en-IN" dirty="0"/>
+              <a:t>Our </a:t>
+            </a:r>
+            <a:r>
+              <a:rPr lang="en-IN" b="1" dirty="0"/>
+              <a:t>dual-model architecture</a:t>
+            </a:r>
+            <a:r>
+              <a:rPr lang="en-IN" dirty="0"/>
+              <a:t> (Module B for Jurisdiction, Module C for Outcome) provides comprehensive case analysis — classifying domain and forecasting decisions in a single workflow.</a:t>
+            </a:r>
+          </a:p>
+          <a:p>
+            <a:pPr marL="285750" indent="-285750">
+              <a:buFont typeface="Arial" panose="020B0604020202020204" pitchFamily="34" charset="0"/>
+              <a:buChar char="•"/>
+            </a:pPr>
+            <a:r>
+              <a:rPr lang="en-IN" dirty="0"/>
+              <a:t>The </a:t>
+            </a:r>
+            <a:r>
+              <a:rPr lang="en-IN" b="1" dirty="0"/>
+              <a:t>IPC-to-BNS translation engine</a:t>
+            </a:r>
+            <a:r>
+              <a:rPr lang="en-IN" dirty="0"/>
+              <a:t> with 80+ statutory mappings addresses a real, urgent need created by India's 2023 penal code transition — making it immediately useful for legal professionals.</a:t>
+            </a:r>
+          </a:p>
+          <a:p>
+            <a:pPr marL="285750" indent="-285750">
+              <a:buFont typeface="Arial" panose="020B0604020202020204" pitchFamily="34" charset="0"/>
+              <a:buChar char="•"/>
+            </a:pPr>
+            <a:r>
+              <a:rPr lang="en-IN" b="1" dirty="0"/>
+              <a:t>Role-based access control</a:t>
+            </a:r>
+            <a:r>
+              <a:rPr lang="en-IN" dirty="0"/>
+              <a:t> with </a:t>
+            </a:r>
+            <a:r>
+              <a:rPr lang="en-IN" dirty="0" err="1"/>
+              <a:t>Supabase</a:t>
+            </a:r>
+            <a:r>
+              <a:rPr lang="en-IN" dirty="0"/>
+              <a:t> authentication ensures that Students, Lawyers, Judges, and Admins each have a secure, tailored experience.</a:t>
+            </a:r>
+          </a:p>
+          <a:p>
+            <a:pPr marL="285750" indent="-285750">
+              <a:buFont typeface="Arial" panose="020B0604020202020204" pitchFamily="34" charset="0"/>
+              <a:buChar char="•"/>
+            </a:pPr>
+            <a:r>
+              <a:rPr lang="en-IN" dirty="0"/>
+              <a:t>The project demonstrates that </a:t>
+            </a:r>
+            <a:r>
+              <a:rPr lang="en-IN" b="1" dirty="0"/>
+              <a:t>domain-specific AI models</a:t>
+            </a:r>
+            <a:r>
+              <a:rPr lang="en-IN" dirty="0"/>
+              <a:t> (InLegalBERT) significantly outperform generic approaches (+23% over baseline), proving the value of specialized NLP in the legal domain.</a:t>
+            </a:r>
+          </a:p>
+        </p:txBody>
+      </p:sp>
+      <p:sp>
+        <p:nvSpPr>
+          <p:cNvPr id="4" name="TextBox 7">
+            <a:extLst>
+              <a:ext uri="{FF2B5EF4-FFF2-40B4-BE49-F238E27FC236}">
+                <a16:creationId xmlns:a16="http://schemas.microsoft.com/office/drawing/2014/main" id="{75E7E2E3-5D39-D2D8-45D7-C9B339A859C6}"/>
+              </a:ext>
+            </a:extLst>
+          </p:cNvPr>
+          <p:cNvSpPr txBox="1">
+            <a:spLocks noChangeArrowheads="1"/>
+          </p:cNvSpPr>
+          <p:nvPr/>
+        </p:nvSpPr>
+        <p:spPr bwMode="auto">
+          <a:xfrm>
+            <a:off x="0" y="1052735"/>
+            <a:ext cx="9180512" cy="338554"/>
+          </a:xfrm>
+          <a:prstGeom prst="rect">
+            <a:avLst/>
+          </a:prstGeom>
+          <a:solidFill>
+            <a:srgbClr val="FFC000"/>
+          </a:solidFill>
+          <a:ln w="9525">
+            <a:noFill/>
+            <a:miter lim="800000"/>
+          </a:ln>
+        </p:spPr>
+        <p:txBody>
+          <a:bodyPr wrap="square">
+            <a:spAutoFit/>
+          </a:bodyPr>
+          <a:lstStyle/>
+          <a:p>
+            <a:pPr algn="ctr"/>
+            <a:r>
+              <a:rPr lang="en-US" sz="1600" b="1" dirty="0">
+                <a:latin typeface="Times New Roman" panose="02020603050405020304" pitchFamily="18" charset="0"/>
+                <a:cs typeface="Times New Roman" panose="02020603050405020304" pitchFamily="18" charset="0"/>
+              </a:rPr>
+              <a:t>Final Presentation </a:t>
+            </a:r>
+            <a:endParaRPr lang="en-IN" sz="1600" b="1" dirty="0">
+              <a:latin typeface="Times New Roman" panose="02020603050405020304" pitchFamily="18" charset="0"/>
+              <a:cs typeface="Times New Roman" panose="02020603050405020304" pitchFamily="18" charset="0"/>
+            </a:endParaRPr>
+          </a:p>
+        </p:txBody>
+      </p:sp>
+    </p:spTree>
+    <p:extLst>
+      <p:ext uri="{BB962C8B-B14F-4D97-AF65-F5344CB8AC3E}">
+        <p14:creationId xmlns:p14="http://schemas.microsoft.com/office/powerpoint/2010/main" val="2714245623"/>
+      </p:ext>
+    </p:extLst>
+  </p:cSld>
+  <p:clrMapOvr>
+    <a:masterClrMapping/>
+  </p:clrMapOvr>
+</p:sld>
+</file>
+
+<file path=ppt/slides/slide17.xml><?xml version="1.0" encoding="utf-8"?>
 <p:sld xmlns:a="http://schemas.openxmlformats.org/drawingml/2006/main" xmlns:r="http://schemas.openxmlformats.org/officeDocument/2006/relationships" xmlns:p="http://schemas.openxmlformats.org/presentationml/2006/main">
   <p:cSld>
     <p:spTree>
@@ -8697,7 +10819,7 @@
                 </a:solidFill>
               </a:rPr>
               <a:pPr/>
-              <a:t>14</a:t>
+              <a:t>17</a:t>
             </a:fld>
             <a:endParaRPr lang="en-GB" b="1" dirty="0">
               <a:solidFill>
@@ -8806,8 +10928,8 @@
         </p:nvSpPr>
         <p:spPr>
           <a:xfrm>
-            <a:off x="317166" y="2564904"/>
-            <a:ext cx="8568952" cy="2554545"/>
+            <a:off x="317166" y="2355845"/>
+            <a:ext cx="8568952" cy="2585323"/>
           </a:xfrm>
           <a:prstGeom prst="rect">
             <a:avLst/>
@@ -8825,8 +10947,12 @@
               <a:buChar char="•"/>
             </a:pPr>
             <a:r>
-              <a:rPr lang="en-US" sz="2000" dirty="0"/>
-              <a:t>Generative AI Integration: Implementing Large Language Models (LLMs) to automatically generate plain-English summaries of complex judgments alongside the predictions.</a:t>
+              <a:rPr lang="en-IN" b="1" dirty="0"/>
+              <a:t>Multilingual Support:</a:t>
+            </a:r>
+            <a:r>
+              <a:rPr lang="en-IN" dirty="0"/>
+              <a:t> Expanding the NLP pipeline to process court documents in regional languages — Hindi, Marathi, and Tamil — using multilingual transformer models.</a:t>
             </a:r>
           </a:p>
           <a:p>
@@ -8835,8 +10961,12 @@
               <a:buChar char="•"/>
             </a:pPr>
             <a:r>
-              <a:rPr lang="en-US" sz="2000" dirty="0"/>
-              <a:t>Regional Expansion: Expanding our JSON mapping dictionaries to include regional state laws and multilingual High Court translations (Marathi, Hindi).</a:t>
+              <a:rPr lang="en-IN" b="1" dirty="0"/>
+              <a:t>Sentence &amp; Penalty Prediction:</a:t>
+            </a:r>
+            <a:r>
+              <a:rPr lang="en-IN" dirty="0"/>
+              <a:t> Extending the model to predict not just outcomes but also estimated imprisonment duration and settlement amounts for civil cases.</a:t>
             </a:r>
           </a:p>
           <a:p>
@@ -8845,9 +10975,78 @@
               <a:buChar char="•"/>
             </a:pPr>
             <a:r>
-              <a:rPr lang="en-US" sz="2000" dirty="0"/>
-              <a:t>Frontend Migration: Rebuilding the Streamlit UI in React.js or Next.js to provide a seamless, native mobile application experience for practicing lawyers on the go.</a:t>
-            </a:r>
+              <a:rPr lang="en-IN" b="1" dirty="0"/>
+              <a:t>Frontend Migration:</a:t>
+            </a:r>
+            <a:r>
+              <a:rPr lang="en-IN" dirty="0"/>
+              <a:t> Rebuilding the Streamlit UI in React.js or Next.js to provide a production-grade, mobile-responsive application for practicing lawyers on the go.</a:t>
+            </a:r>
+          </a:p>
+          <a:p>
+            <a:pPr marL="285750" indent="-285750" algn="just">
+              <a:buFont typeface="Arial" panose="020B0604020202020204" pitchFamily="34" charset="0"/>
+              <a:buChar char="•"/>
+            </a:pPr>
+            <a:r>
+              <a:rPr lang="en-IN" b="1" dirty="0"/>
+              <a:t>REST API Deployment:</a:t>
+            </a:r>
+            <a:r>
+              <a:rPr lang="en-IN" dirty="0"/>
+              <a:t> Exposing the prediction models as RESTful APIs so third-party legal-tech platforms can integrate our predictions into their workflows.</a:t>
+            </a:r>
+          </a:p>
+        </p:txBody>
+      </p:sp>
+      <p:sp>
+        <p:nvSpPr>
+          <p:cNvPr id="4" name="TextBox 7">
+            <a:extLst>
+              <a:ext uri="{FF2B5EF4-FFF2-40B4-BE49-F238E27FC236}">
+                <a16:creationId xmlns:a16="http://schemas.microsoft.com/office/drawing/2014/main" id="{C8D657D4-FE9E-BB8F-9DC6-84F956DB1018}"/>
+              </a:ext>
+            </a:extLst>
+          </p:cNvPr>
+          <p:cNvSpPr txBox="1">
+            <a:spLocks noChangeArrowheads="1"/>
+          </p:cNvSpPr>
+          <p:nvPr/>
+        </p:nvSpPr>
+        <p:spPr bwMode="auto">
+          <a:xfrm>
+            <a:off x="0" y="1052735"/>
+            <a:ext cx="9180512" cy="338554"/>
+          </a:xfrm>
+          <a:prstGeom prst="rect">
+            <a:avLst/>
+          </a:prstGeom>
+          <a:solidFill>
+            <a:srgbClr val="FFC000"/>
+          </a:solidFill>
+          <a:ln w="9525">
+            <a:noFill/>
+            <a:miter lim="800000"/>
+          </a:ln>
+        </p:spPr>
+        <p:txBody>
+          <a:bodyPr wrap="square">
+            <a:spAutoFit/>
+          </a:bodyPr>
+          <a:lstStyle/>
+          <a:p>
+            <a:pPr algn="ctr"/>
+            <a:r>
+              <a:rPr lang="en-US" sz="1600" b="1" dirty="0">
+                <a:latin typeface="Times New Roman" panose="02020603050405020304" pitchFamily="18" charset="0"/>
+                <a:cs typeface="Times New Roman" panose="02020603050405020304" pitchFamily="18" charset="0"/>
+              </a:rPr>
+              <a:t>Final Presentation </a:t>
+            </a:r>
+            <a:endParaRPr lang="en-IN" sz="1600" b="1" dirty="0">
+              <a:latin typeface="Times New Roman" panose="02020603050405020304" pitchFamily="18" charset="0"/>
+              <a:cs typeface="Times New Roman" panose="02020603050405020304" pitchFamily="18" charset="0"/>
+            </a:endParaRPr>
           </a:p>
         </p:txBody>
       </p:sp>
@@ -8864,7 +11063,7 @@
 </p:sld>
 </file>
 
-<file path=ppt/slides/slide15.xml><?xml version="1.0" encoding="utf-8"?>
+<file path=ppt/slides/slide18.xml><?xml version="1.0" encoding="utf-8"?>
 <p:sld xmlns:a="http://schemas.openxmlformats.org/drawingml/2006/main" xmlns:r="http://schemas.openxmlformats.org/officeDocument/2006/relationships" xmlns:p="http://schemas.openxmlformats.org/presentationml/2006/main">
   <p:cSld>
     <p:spTree>
@@ -9097,7 +11296,7 @@
                 </a:solidFill>
               </a:rPr>
               <a:pPr/>
-              <a:t>15</a:t>
+              <a:t>18</a:t>
             </a:fld>
             <a:endParaRPr lang="en-GB" b="1" dirty="0">
               <a:solidFill>
@@ -9395,6 +11594,57 @@
           </a:p>
         </p:txBody>
       </p:sp>
+      <p:sp>
+        <p:nvSpPr>
+          <p:cNvPr id="5" name="TextBox 7">
+            <a:extLst>
+              <a:ext uri="{FF2B5EF4-FFF2-40B4-BE49-F238E27FC236}">
+                <a16:creationId xmlns:a16="http://schemas.microsoft.com/office/drawing/2014/main" id="{8E510494-F5A8-5AE1-5A8D-2FAC8694DDCB}"/>
+              </a:ext>
+            </a:extLst>
+          </p:cNvPr>
+          <p:cNvSpPr txBox="1">
+            <a:spLocks noChangeArrowheads="1"/>
+          </p:cNvSpPr>
+          <p:nvPr/>
+        </p:nvSpPr>
+        <p:spPr bwMode="auto">
+          <a:xfrm>
+            <a:off x="0" y="1052735"/>
+            <a:ext cx="9180512" cy="338554"/>
+          </a:xfrm>
+          <a:prstGeom prst="rect">
+            <a:avLst/>
+          </a:prstGeom>
+          <a:solidFill>
+            <a:srgbClr val="FFC000"/>
+          </a:solidFill>
+          <a:ln w="9525">
+            <a:noFill/>
+            <a:miter lim="800000"/>
+          </a:ln>
+        </p:spPr>
+        <p:txBody>
+          <a:bodyPr wrap="square">
+            <a:spAutoFit/>
+          </a:bodyPr>
+          <a:lstStyle/>
+          <a:p>
+            <a:pPr algn="ctr"/>
+            <a:r>
+              <a:rPr lang="en-US" sz="1600" b="1" dirty="0">
+                <a:latin typeface="Times New Roman" panose="02020603050405020304" pitchFamily="18" charset="0"/>
+                <a:cs typeface="Times New Roman" panose="02020603050405020304" pitchFamily="18" charset="0"/>
+              </a:rPr>
+              <a:t>Final Presentation </a:t>
+            </a:r>
+            <a:endParaRPr lang="en-IN" sz="1600" b="1" dirty="0">
+              <a:latin typeface="Times New Roman" panose="02020603050405020304" pitchFamily="18" charset="0"/>
+              <a:cs typeface="Times New Roman" panose="02020603050405020304" pitchFamily="18" charset="0"/>
+            </a:endParaRPr>
+          </a:p>
+        </p:txBody>
+      </p:sp>
     </p:spTree>
     <p:extLst>
       <p:ext uri="{BB962C8B-B14F-4D97-AF65-F5344CB8AC3E}">
@@ -9408,7 +11658,7 @@
 </p:sld>
 </file>
 
-<file path=ppt/slides/slide16.xml><?xml version="1.0" encoding="utf-8"?>
+<file path=ppt/slides/slide19.xml><?xml version="1.0" encoding="utf-8"?>
 <p:sld xmlns:a="http://schemas.openxmlformats.org/drawingml/2006/main" xmlns:r="http://schemas.openxmlformats.org/officeDocument/2006/relationships" xmlns:p="http://schemas.openxmlformats.org/presentationml/2006/main">
   <p:cSld>
     <p:spTree>
@@ -9671,7 +11921,7 @@
                 </a:solidFill>
               </a:rPr>
               <a:pPr/>
-              <a:t>16</a:t>
+              <a:t>19</a:t>
             </a:fld>
             <a:endParaRPr lang="en-GB" b="1" dirty="0">
               <a:solidFill>
@@ -9898,6 +12148,57 @@
           </a:p>
         </p:txBody>
       </p:sp>
+      <p:sp>
+        <p:nvSpPr>
+          <p:cNvPr id="5" name="TextBox 7">
+            <a:extLst>
+              <a:ext uri="{FF2B5EF4-FFF2-40B4-BE49-F238E27FC236}">
+                <a16:creationId xmlns:a16="http://schemas.microsoft.com/office/drawing/2014/main" id="{C31D7689-6456-6A4B-9BE9-C231883C1DB2}"/>
+              </a:ext>
+            </a:extLst>
+          </p:cNvPr>
+          <p:cNvSpPr txBox="1">
+            <a:spLocks noChangeArrowheads="1"/>
+          </p:cNvSpPr>
+          <p:nvPr/>
+        </p:nvSpPr>
+        <p:spPr bwMode="auto">
+          <a:xfrm>
+            <a:off x="0" y="1052735"/>
+            <a:ext cx="9180512" cy="338554"/>
+          </a:xfrm>
+          <a:prstGeom prst="rect">
+            <a:avLst/>
+          </a:prstGeom>
+          <a:solidFill>
+            <a:srgbClr val="FFC000"/>
+          </a:solidFill>
+          <a:ln w="9525">
+            <a:noFill/>
+            <a:miter lim="800000"/>
+          </a:ln>
+        </p:spPr>
+        <p:txBody>
+          <a:bodyPr wrap="square">
+            <a:spAutoFit/>
+          </a:bodyPr>
+          <a:lstStyle/>
+          <a:p>
+            <a:pPr algn="ctr"/>
+            <a:r>
+              <a:rPr lang="en-US" sz="1600" b="1" dirty="0">
+                <a:latin typeface="Times New Roman" panose="02020603050405020304" pitchFamily="18" charset="0"/>
+                <a:cs typeface="Times New Roman" panose="02020603050405020304" pitchFamily="18" charset="0"/>
+              </a:rPr>
+              <a:t>Final Presentation </a:t>
+            </a:r>
+            <a:endParaRPr lang="en-IN" sz="1600" b="1" dirty="0">
+              <a:latin typeface="Times New Roman" panose="02020603050405020304" pitchFamily="18" charset="0"/>
+              <a:cs typeface="Times New Roman" panose="02020603050405020304" pitchFamily="18" charset="0"/>
+            </a:endParaRPr>
+          </a:p>
+        </p:txBody>
+      </p:sp>
     </p:spTree>
     <p:extLst>
       <p:ext uri="{BB962C8B-B14F-4D97-AF65-F5344CB8AC3E}">
@@ -10296,6 +12597,57 @@
           </a:p>
         </p:txBody>
       </p:sp>
+      <p:sp>
+        <p:nvSpPr>
+          <p:cNvPr id="3" name="TextBox 7">
+            <a:extLst>
+              <a:ext uri="{FF2B5EF4-FFF2-40B4-BE49-F238E27FC236}">
+                <a16:creationId xmlns:a16="http://schemas.microsoft.com/office/drawing/2014/main" id="{01D842EF-79FC-42F9-4FE5-4661FDB72F61}"/>
+              </a:ext>
+            </a:extLst>
+          </p:cNvPr>
+          <p:cNvSpPr txBox="1">
+            <a:spLocks noChangeArrowheads="1"/>
+          </p:cNvSpPr>
+          <p:nvPr/>
+        </p:nvSpPr>
+        <p:spPr bwMode="auto">
+          <a:xfrm>
+            <a:off x="0" y="1052735"/>
+            <a:ext cx="9180512" cy="338554"/>
+          </a:xfrm>
+          <a:prstGeom prst="rect">
+            <a:avLst/>
+          </a:prstGeom>
+          <a:solidFill>
+            <a:srgbClr val="FFC000"/>
+          </a:solidFill>
+          <a:ln w="9525">
+            <a:noFill/>
+            <a:miter lim="800000"/>
+          </a:ln>
+        </p:spPr>
+        <p:txBody>
+          <a:bodyPr wrap="square">
+            <a:spAutoFit/>
+          </a:bodyPr>
+          <a:lstStyle/>
+          <a:p>
+            <a:pPr algn="ctr"/>
+            <a:r>
+              <a:rPr lang="en-US" sz="1600" b="1" dirty="0">
+                <a:latin typeface="Times New Roman" panose="02020603050405020304" pitchFamily="18" charset="0"/>
+                <a:cs typeface="Times New Roman" panose="02020603050405020304" pitchFamily="18" charset="0"/>
+              </a:rPr>
+              <a:t>Final Presentation </a:t>
+            </a:r>
+            <a:endParaRPr lang="en-IN" sz="1600" b="1" dirty="0">
+              <a:latin typeface="Times New Roman" panose="02020603050405020304" pitchFamily="18" charset="0"/>
+              <a:cs typeface="Times New Roman" panose="02020603050405020304" pitchFamily="18" charset="0"/>
+            </a:endParaRPr>
+          </a:p>
+        </p:txBody>
+      </p:sp>
     </p:spTree>
     <p:extLst>
       <p:ext uri="{BB962C8B-B14F-4D97-AF65-F5344CB8AC3E}">
@@ -10639,8 +12991,8 @@
         </p:nvSpPr>
         <p:spPr>
           <a:xfrm>
-            <a:off x="539076" y="2444695"/>
-            <a:ext cx="8102359" cy="3139321"/>
+            <a:off x="539076" y="2255961"/>
+            <a:ext cx="8102359" cy="3693319"/>
           </a:xfrm>
           <a:prstGeom prst="rect">
             <a:avLst/>
@@ -10653,48 +13005,149 @@
           </a:bodyPr>
           <a:lstStyle/>
           <a:p>
-            <a:pPr algn="just"/>
-            <a:r>
-              <a:rPr lang="en-US" dirty="0"/>
-              <a:t>The legal system suffers from a massive backlog, with judgments spanning hundreds of unstructured pages. Applying standard AI introduces three major roadblocks:</a:t>
-            </a:r>
-          </a:p>
-          <a:p>
-            <a:pPr algn="just"/>
-            <a:endParaRPr lang="en-US" dirty="0"/>
-          </a:p>
-          <a:p>
-            <a:pPr algn="just"/>
-            <a:r>
-              <a:rPr lang="en-US" b="1" dirty="0"/>
-              <a:t>1. Token Limits &amp; Data Leakage:</a:t>
-            </a:r>
-            <a:r>
-              <a:rPr lang="en-US" dirty="0"/>
-              <a:t> Standard models crash on documents over 512 tokens, or they accidentally read the judge's final verdict while trying to predict it (data leakage).</a:t>
-            </a:r>
-          </a:p>
-          <a:p>
-            <a:pPr algn="just"/>
-            <a:r>
-              <a:rPr lang="en-US" b="1" dirty="0"/>
-              <a:t>2. Statutory Transitions: </a:t>
-            </a:r>
-            <a:r>
-              <a:rPr lang="en-US" dirty="0"/>
-              <a:t>India's shift from the Indian Penal Code (IPC) to the Bharatiya Nyaya Sanhita (BNS) makes legacy AI models instantly obsolete, as they don't understand the new laws.</a:t>
-            </a:r>
-          </a:p>
-          <a:p>
-            <a:pPr algn="just"/>
-            <a:r>
-              <a:rPr lang="en-US" b="1" dirty="0"/>
-              <a:t>3. The "Black Box" Trust Issue: </a:t>
-            </a:r>
-            <a:r>
-              <a:rPr lang="en-US" dirty="0"/>
-              <a:t>Legal professionals cannot trust an AI that predicts "Dismissed" without providing clear, verifiable legal reasoning.</a:t>
-            </a:r>
+            <a:pPr marL="285750" indent="-285750">
+              <a:buFont typeface="Arial" panose="020B0604020202020204" pitchFamily="34" charset="0"/>
+              <a:buChar char="•"/>
+            </a:pPr>
+            <a:r>
+              <a:rPr lang="en-IN" dirty="0"/>
+              <a:t>India's judiciary has </a:t>
+            </a:r>
+            <a:r>
+              <a:rPr lang="en-IN" b="1" dirty="0"/>
+              <a:t>over 5 crore pending cases</a:t>
+            </a:r>
+            <a:r>
+              <a:rPr lang="en-IN" dirty="0"/>
+              <a:t> across the Supreme Court, 25 High Courts, and 700+ District Courts — one of the largest judicial backlogs globally.</a:t>
+            </a:r>
+          </a:p>
+          <a:p>
+            <a:pPr marL="285750" indent="-285750">
+              <a:buFont typeface="Arial" panose="020B0604020202020204" pitchFamily="34" charset="0"/>
+              <a:buChar char="•"/>
+            </a:pPr>
+            <a:r>
+              <a:rPr lang="en-IN" dirty="0"/>
+              <a:t>Court judgments are </a:t>
+            </a:r>
+            <a:r>
+              <a:rPr lang="en-IN" b="1" dirty="0"/>
+              <a:t>lengthy, unstructured PDFs</a:t>
+            </a:r>
+            <a:r>
+              <a:rPr lang="en-IN" dirty="0"/>
+              <a:t> (20–100+ pages) written in complex legal English, making manual analysis extremely time-consuming.</a:t>
+            </a:r>
+          </a:p>
+          <a:p>
+            <a:pPr marL="285750" indent="-285750">
+              <a:buFont typeface="Arial" panose="020B0604020202020204" pitchFamily="34" charset="0"/>
+              <a:buChar char="•"/>
+            </a:pPr>
+            <a:r>
+              <a:rPr lang="en-IN" b="1" dirty="0"/>
+              <a:t>No domain-specific AI tool</a:t>
+            </a:r>
+            <a:r>
+              <a:rPr lang="en-IN" dirty="0"/>
+              <a:t> exists for the Indian legal system — generic LLMs like GPT lack understanding of Indian statutes, FIR terminology, and case law structures.</a:t>
+            </a:r>
+          </a:p>
+          <a:p>
+            <a:pPr marL="285750" indent="-285750">
+              <a:buFont typeface="Arial" panose="020B0604020202020204" pitchFamily="34" charset="0"/>
+              <a:buChar char="•"/>
+            </a:pPr>
+            <a:r>
+              <a:rPr lang="en-IN" dirty="0"/>
+              <a:t>India's 2023 transition from the </a:t>
+            </a:r>
+            <a:r>
+              <a:rPr lang="en-IN" b="1" dirty="0"/>
+              <a:t>Indian Penal Code (IPC, 1860)</a:t>
+            </a:r>
+            <a:r>
+              <a:rPr lang="en-IN" dirty="0"/>
+              <a:t> to the </a:t>
+            </a:r>
+            <a:r>
+              <a:rPr lang="en-IN" b="1" dirty="0"/>
+              <a:t>Bharatiya Nyaya Sanhita (BNS)</a:t>
+            </a:r>
+            <a:r>
+              <a:rPr lang="en-IN" dirty="0"/>
+              <a:t> has created widespread confusion among legal professionals due to renumbered sections.</a:t>
+            </a:r>
+          </a:p>
+          <a:p>
+            <a:pPr marL="285750" indent="-285750">
+              <a:buFont typeface="Arial" panose="020B0604020202020204" pitchFamily="34" charset="0"/>
+              <a:buChar char="•"/>
+            </a:pPr>
+            <a:r>
+              <a:rPr lang="en-IN" dirty="0"/>
+              <a:t>Lawyers and litigants </a:t>
+            </a:r>
+            <a:r>
+              <a:rPr lang="en-IN" b="1" dirty="0"/>
+              <a:t>lack predictive insight</a:t>
+            </a:r>
+            <a:r>
+              <a:rPr lang="en-IN" dirty="0"/>
+              <a:t> into case outcomes, leading to uncertainty, wasted effort, and delayed justice.</a:t>
+            </a:r>
+          </a:p>
+        </p:txBody>
+      </p:sp>
+      <p:sp>
+        <p:nvSpPr>
+          <p:cNvPr id="3" name="TextBox 7">
+            <a:extLst>
+              <a:ext uri="{FF2B5EF4-FFF2-40B4-BE49-F238E27FC236}">
+                <a16:creationId xmlns:a16="http://schemas.microsoft.com/office/drawing/2014/main" id="{6A22E1C6-F26F-D9DA-67D9-3F36718510DF}"/>
+              </a:ext>
+            </a:extLst>
+          </p:cNvPr>
+          <p:cNvSpPr txBox="1">
+            <a:spLocks noChangeArrowheads="1"/>
+          </p:cNvSpPr>
+          <p:nvPr/>
+        </p:nvSpPr>
+        <p:spPr bwMode="auto">
+          <a:xfrm>
+            <a:off x="0" y="1052736"/>
+            <a:ext cx="9180512" cy="338554"/>
+          </a:xfrm>
+          <a:prstGeom prst="rect">
+            <a:avLst/>
+          </a:prstGeom>
+          <a:solidFill>
+            <a:srgbClr val="FFC000"/>
+          </a:solidFill>
+          <a:ln w="9525">
+            <a:noFill/>
+            <a:miter lim="800000"/>
+          </a:ln>
+        </p:spPr>
+        <p:txBody>
+          <a:bodyPr wrap="square">
+            <a:spAutoFit/>
+          </a:bodyPr>
+          <a:lstStyle/>
+          <a:p>
+            <a:pPr algn="ctr"/>
+            <a:r>
+              <a:rPr lang="en-US" sz="1600" b="1" dirty="0">
+                <a:latin typeface="Times New Roman" panose="02020603050405020304" pitchFamily="18" charset="0"/>
+                <a:cs typeface="Times New Roman" panose="02020603050405020304" pitchFamily="18" charset="0"/>
+              </a:rPr>
+              <a:t>Final Presentation </a:t>
+            </a:r>
+            <a:endParaRPr lang="en-IN" sz="1600" b="1" dirty="0">
+              <a:latin typeface="Times New Roman" panose="02020603050405020304" pitchFamily="18" charset="0"/>
+              <a:cs typeface="Times New Roman" panose="02020603050405020304" pitchFamily="18" charset="0"/>
+            </a:endParaRPr>
           </a:p>
         </p:txBody>
       </p:sp>
@@ -11038,8 +13491,8 @@
         </p:nvSpPr>
         <p:spPr>
           <a:xfrm>
-            <a:off x="467544" y="2399402"/>
-            <a:ext cx="8280920" cy="3477875"/>
+            <a:off x="467544" y="2348880"/>
+            <a:ext cx="8280920" cy="4247317"/>
           </a:xfrm>
           <a:prstGeom prst="rect">
             <a:avLst/>
@@ -11056,12 +13509,12 @@
               <a:buChar char="•"/>
             </a:pPr>
             <a:r>
-              <a:rPr lang="en-IN" sz="2000" b="1" dirty="0"/>
+              <a:rPr lang="en-IN" b="1" dirty="0"/>
               <a:t>Structure-Aware Chunking:</a:t>
             </a:r>
             <a:r>
-              <a:rPr lang="en-IN" sz="2000" dirty="0"/>
-              <a:t> Engineered a custom Regex pipeline to specifically isolate 'Facts' and 'Arguments', bypassing token limits and preventing data leakage.</a:t>
+              <a:rPr lang="en-IN" dirty="0"/>
+              <a:t> Engineered a custom Regex pipeline to specifically isolate 'Facts' and 'Arguments' sections from unstructured judgments, bypassing BERT's 512-token limit and feeding only legally relevant text.</a:t>
             </a:r>
           </a:p>
           <a:p>
@@ -11070,12 +13523,20 @@
               <a:buChar char="•"/>
             </a:pPr>
             <a:r>
-              <a:rPr lang="en-IN" sz="2000" b="1" dirty="0"/>
+              <a:rPr lang="en-IN" b="1" dirty="0"/>
               <a:t>Dynamic JSON Middleware:</a:t>
             </a:r>
             <a:r>
-              <a:rPr lang="en-IN" sz="2000" dirty="0"/>
-              <a:t> Built an automated translation layer that seamlessly maps historical IPC sections to modern BNS equivalents before AI inference.</a:t>
+              <a:rPr lang="en-IN" dirty="0"/>
+              <a:t> Built an automated IPC-to-BNS translation layer (80+ mappings in </a:t>
+            </a:r>
+            <a:r>
+              <a:rPr lang="en-IN" dirty="0" err="1"/>
+              <a:t>bns_mapping.json</a:t>
+            </a:r>
+            <a:r>
+              <a:rPr lang="en-IN" dirty="0"/>
+              <a:t>) that seamlessly converts legacy IPC section references to modern BNS equivalents before AI inference.</a:t>
             </a:r>
           </a:p>
           <a:p>
@@ -11084,12 +13545,20 @@
               <a:buChar char="•"/>
             </a:pPr>
             <a:r>
-              <a:rPr lang="en-IN" sz="2000" b="1" dirty="0"/>
+              <a:rPr lang="en-IN" b="1" dirty="0"/>
               <a:t>Dual-Inference Pipeline:</a:t>
             </a:r>
             <a:r>
-              <a:rPr lang="en-IN" sz="2000" dirty="0"/>
-              <a:t> Utilizes InLegalBERT to instantly predict both Jurisdiction and Appellate Outcome with 85.2% accuracy.</a:t>
+              <a:rPr lang="en-IN" dirty="0"/>
+              <a:t> Two separately fine-tuned InLegalBERT models — Module B classifies Jurisdiction (Civil / Criminal / Constitutional) and Module C predicts Appellate Outcome (Allowed / Dismissed) — achieving </a:t>
+            </a:r>
+            <a:r>
+              <a:rPr lang="en-IN" b="1" dirty="0"/>
+              <a:t>85.2% accuracy</a:t>
+            </a:r>
+            <a:r>
+              <a:rPr lang="en-IN" dirty="0"/>
+              <a:t>.</a:t>
             </a:r>
           </a:p>
           <a:p>
@@ -11098,21 +13567,86 @@
               <a:buChar char="•"/>
             </a:pPr>
             <a:r>
-              <a:rPr lang="en-IN" sz="2000" b="1" dirty="0"/>
-              <a:t>NER-Filtered Explainability: </a:t>
-            </a:r>
-            <a:r>
-              <a:rPr lang="en-IN" sz="2000" dirty="0"/>
-              <a:t>Integrated SHAP with </a:t>
-            </a:r>
-            <a:r>
-              <a:rPr lang="en-IN" sz="2000" dirty="0" err="1"/>
-              <a:t>spaCy</a:t>
-            </a:r>
-            <a:r>
-              <a:rPr lang="en-IN" sz="2000" dirty="0"/>
-              <a:t> (NER) to highlight only critical legal statutes and entities, ensuring zero-noise transparency for lawyers.</a:t>
-            </a:r>
+              <a:rPr lang="en-IN" b="1" dirty="0"/>
+              <a:t>Role-Based Access Control:</a:t>
+            </a:r>
+            <a:r>
+              <a:rPr lang="en-IN" dirty="0"/>
+              <a:t> Four user roles (Student, Lawyer, Judge, Admin) with </a:t>
+            </a:r>
+            <a:r>
+              <a:rPr lang="en-IN" dirty="0" err="1"/>
+              <a:t>Supabase</a:t>
+            </a:r>
+            <a:r>
+              <a:rPr lang="en-IN" dirty="0"/>
+              <a:t> authentication and Row Level Security, ensuring each user only accesses authorized modules and their own data.</a:t>
+            </a:r>
+          </a:p>
+          <a:p>
+            <a:pPr marL="285750" indent="-285750" algn="just">
+              <a:buFont typeface="Arial" panose="020B0604020202020204" pitchFamily="34" charset="0"/>
+              <a:buChar char="•"/>
+            </a:pPr>
+            <a:r>
+              <a:rPr lang="en-IN" b="1" dirty="0"/>
+              <a:t>Cloud-Backed Audit Trail:</a:t>
+            </a:r>
+            <a:r>
+              <a:rPr lang="en-IN" dirty="0"/>
+              <a:t> Every prediction is automatically logged to a PostgreSQL database with timestamps, confidence scores, and file references for full traceability.</a:t>
+            </a:r>
+          </a:p>
+        </p:txBody>
+      </p:sp>
+      <p:sp>
+        <p:nvSpPr>
+          <p:cNvPr id="5" name="TextBox 7">
+            <a:extLst>
+              <a:ext uri="{FF2B5EF4-FFF2-40B4-BE49-F238E27FC236}">
+                <a16:creationId xmlns:a16="http://schemas.microsoft.com/office/drawing/2014/main" id="{CD117D83-5A9E-A2F3-5AC3-66AB6B7D7137}"/>
+              </a:ext>
+            </a:extLst>
+          </p:cNvPr>
+          <p:cNvSpPr txBox="1">
+            <a:spLocks noChangeArrowheads="1"/>
+          </p:cNvSpPr>
+          <p:nvPr/>
+        </p:nvSpPr>
+        <p:spPr bwMode="auto">
+          <a:xfrm>
+            <a:off x="0" y="1052735"/>
+            <a:ext cx="9180512" cy="338554"/>
+          </a:xfrm>
+          <a:prstGeom prst="rect">
+            <a:avLst/>
+          </a:prstGeom>
+          <a:solidFill>
+            <a:srgbClr val="FFC000"/>
+          </a:solidFill>
+          <a:ln w="9525">
+            <a:noFill/>
+            <a:miter lim="800000"/>
+          </a:ln>
+        </p:spPr>
+        <p:txBody>
+          <a:bodyPr wrap="square">
+            <a:spAutoFit/>
+          </a:bodyPr>
+          <a:lstStyle/>
+          <a:p>
+            <a:pPr algn="ctr"/>
+            <a:r>
+              <a:rPr lang="en-US" sz="1600" b="1" dirty="0">
+                <a:latin typeface="Times New Roman" panose="02020603050405020304" pitchFamily="18" charset="0"/>
+                <a:cs typeface="Times New Roman" panose="02020603050405020304" pitchFamily="18" charset="0"/>
+              </a:rPr>
+              <a:t>Final Presentation </a:t>
+            </a:r>
+            <a:endParaRPr lang="en-IN" sz="1600" b="1" dirty="0">
+              <a:latin typeface="Times New Roman" panose="02020603050405020304" pitchFamily="18" charset="0"/>
+              <a:cs typeface="Times New Roman" panose="02020603050405020304" pitchFamily="18" charset="0"/>
+            </a:endParaRPr>
           </a:p>
         </p:txBody>
       </p:sp>
@@ -11425,8 +13959,8 @@
         </p:nvSpPr>
         <p:spPr bwMode="auto">
           <a:xfrm>
-            <a:off x="404608" y="2425187"/>
-            <a:ext cx="8407808" cy="3416320"/>
+            <a:off x="404608" y="2113686"/>
+            <a:ext cx="8407808" cy="4339650"/>
           </a:xfrm>
           <a:prstGeom prst="rect">
             <a:avLst/>
@@ -11476,64 +14010,64 @@
           <a:p>
             <a:pPr algn="just"/>
             <a:r>
-              <a:rPr lang="en-US" sz="2000" b="1" dirty="0"/>
-              <a:t>Objective 1</a:t>
-            </a:r>
-            <a:r>
-              <a:rPr lang="en-US" sz="2000" dirty="0"/>
-              <a:t>: Curate a real-world corpus of Indian judicial data from the Supreme Court and High Courts.</a:t>
+              <a:rPr lang="en-IN" sz="2000" b="1" dirty="0"/>
+              <a:t>Objective 1:</a:t>
+            </a:r>
+            <a:r>
+              <a:rPr lang="en-IN" sz="2000" dirty="0"/>
+              <a:t> Curate a real-world corpus of Indian judicial data from Supreme Court and High Court appellate records.</a:t>
             </a:r>
           </a:p>
           <a:p>
             <a:pPr algn="just"/>
             <a:r>
-              <a:rPr lang="en-US" sz="2000" b="1" dirty="0"/>
-              <a:t>Objective 2</a:t>
-            </a:r>
-            <a:r>
-              <a:rPr lang="en-US" sz="2000" dirty="0"/>
-              <a:t>: Engineer a robust NLP pipeline using PyMuPDF and Structure-Aware Chunking to extract core case facts.</a:t>
+              <a:rPr lang="en-IN" sz="2000" b="1" dirty="0"/>
+              <a:t>Objective 2:</a:t>
+            </a:r>
+            <a:r>
+              <a:rPr lang="en-IN" sz="2000" dirty="0"/>
+              <a:t> Engineer a robust NLP pipeline using PyMuPDF and Structure-Aware Chunking to extract core case facts, arguments, and judgment sections from raw PDFs.</a:t>
             </a:r>
           </a:p>
           <a:p>
             <a:pPr algn="just"/>
             <a:r>
-              <a:rPr lang="en-US" sz="2000" b="1" dirty="0"/>
-              <a:t>Objective 3</a:t>
-            </a:r>
-            <a:r>
-              <a:rPr lang="en-US" sz="2000" dirty="0"/>
-              <a:t>: Implement a dynamic translation layer to bridge the gap between historical IPC laws and the new BNS framework.</a:t>
+              <a:rPr lang="en-IN" sz="2000" b="1" dirty="0"/>
+              <a:t>Objective 3:</a:t>
+            </a:r>
+            <a:r>
+              <a:rPr lang="en-IN" sz="2000" dirty="0"/>
+              <a:t> Implement a dynamic IPC-to-BNS translation layer with 80+ statutory section mappings to bridge legacy and modern penal codes.</a:t>
             </a:r>
           </a:p>
           <a:p>
             <a:pPr algn="just"/>
             <a:r>
-              <a:rPr lang="en-US" sz="2000" b="1" dirty="0"/>
-              <a:t>Objective 4</a:t>
-            </a:r>
-            <a:r>
-              <a:rPr lang="en-US" sz="2000" dirty="0"/>
-              <a:t>: Train and deploy a high-accuracy InLegalBERT transformer model for binary outcome prediction.</a:t>
+              <a:rPr lang="en-IN" sz="2000" b="1" dirty="0"/>
+              <a:t>Objective 4:</a:t>
+            </a:r>
+            <a:r>
+              <a:rPr lang="en-IN" sz="2000" dirty="0"/>
+              <a:t> Train and deploy a dual-inference InLegalBERT transformer pipeline — one model for jurisdiction classification (3-class) and one for outcome prediction (binary).</a:t>
             </a:r>
           </a:p>
           <a:p>
             <a:pPr algn="just"/>
             <a:r>
-              <a:rPr lang="en-US" sz="2000" b="1" dirty="0"/>
-              <a:t>Objective 5</a:t>
-            </a:r>
-            <a:r>
-              <a:rPr lang="en-US" sz="2000" dirty="0"/>
-              <a:t>: Develop a fully secure, cloud-based SaaS dashboard (</a:t>
-            </a:r>
-            <a:r>
-              <a:rPr lang="en-US" sz="2000" dirty="0" err="1"/>
+              <a:rPr lang="en-IN" sz="2000" b="1" dirty="0"/>
+              <a:t>Objective 5:</a:t>
+            </a:r>
+            <a:r>
+              <a:rPr lang="en-IN" sz="2000" dirty="0"/>
+              <a:t> Develop a secure, role-based SaaS dashboard (Streamlit + </a:t>
+            </a:r>
+            <a:r>
+              <a:rPr lang="en-IN" sz="2000" dirty="0" err="1"/>
               <a:t>Supabase</a:t>
             </a:r>
             <a:r>
-              <a:rPr lang="en-US" sz="2000" dirty="0"/>
-              <a:t> + Streamlit) with transparent AI reasoning.</a:t>
+              <a:rPr lang="en-IN" sz="2000" dirty="0"/>
+              <a:t>) with authenticated access for Students, Lawyers, Judges, and Admins.</a:t>
             </a:r>
           </a:p>
         </p:txBody>
@@ -11628,6 +14162,57 @@
           </a:p>
         </p:txBody>
       </p:sp>
+      <p:sp>
+        <p:nvSpPr>
+          <p:cNvPr id="3" name="TextBox 7">
+            <a:extLst>
+              <a:ext uri="{FF2B5EF4-FFF2-40B4-BE49-F238E27FC236}">
+                <a16:creationId xmlns:a16="http://schemas.microsoft.com/office/drawing/2014/main" id="{94349959-F21E-71BC-268F-B1C403270493}"/>
+              </a:ext>
+            </a:extLst>
+          </p:cNvPr>
+          <p:cNvSpPr txBox="1">
+            <a:spLocks noChangeArrowheads="1"/>
+          </p:cNvSpPr>
+          <p:nvPr/>
+        </p:nvSpPr>
+        <p:spPr bwMode="auto">
+          <a:xfrm>
+            <a:off x="0" y="1052735"/>
+            <a:ext cx="9180512" cy="338554"/>
+          </a:xfrm>
+          <a:prstGeom prst="rect">
+            <a:avLst/>
+          </a:prstGeom>
+          <a:solidFill>
+            <a:srgbClr val="FFC000"/>
+          </a:solidFill>
+          <a:ln w="9525">
+            <a:noFill/>
+            <a:miter lim="800000"/>
+          </a:ln>
+        </p:spPr>
+        <p:txBody>
+          <a:bodyPr wrap="square">
+            <a:spAutoFit/>
+          </a:bodyPr>
+          <a:lstStyle/>
+          <a:p>
+            <a:pPr algn="ctr"/>
+            <a:r>
+              <a:rPr lang="en-US" sz="1600" b="1" dirty="0">
+                <a:latin typeface="Times New Roman" panose="02020603050405020304" pitchFamily="18" charset="0"/>
+                <a:cs typeface="Times New Roman" panose="02020603050405020304" pitchFamily="18" charset="0"/>
+              </a:rPr>
+              <a:t>Final Presentation </a:t>
+            </a:r>
+            <a:endParaRPr lang="en-IN" sz="1600" b="1" dirty="0">
+              <a:latin typeface="Times New Roman" panose="02020603050405020304" pitchFamily="18" charset="0"/>
+              <a:cs typeface="Times New Roman" panose="02020603050405020304" pitchFamily="18" charset="0"/>
+            </a:endParaRPr>
+          </a:p>
+        </p:txBody>
+      </p:sp>
     </p:spTree>
     <p:extLst>
       <p:ext uri="{BB962C8B-B14F-4D97-AF65-F5344CB8AC3E}">
@@ -11935,8 +14520,8 @@
         </p:nvSpPr>
         <p:spPr bwMode="auto">
           <a:xfrm rot="10800000" flipV="1">
-            <a:off x="257111" y="2316774"/>
-            <a:ext cx="8629778" cy="3785652"/>
+            <a:off x="257111" y="1808943"/>
+            <a:ext cx="8629778" cy="4801314"/>
           </a:xfrm>
           <a:prstGeom prst="rect">
             <a:avLst/>
@@ -11989,12 +14574,20 @@
               <a:buChar char="•"/>
             </a:pPr>
             <a:r>
-              <a:rPr lang="en-US" sz="2000" b="1" dirty="0"/>
-              <a:t>Data Extraction</a:t>
-            </a:r>
-            <a:r>
-              <a:rPr lang="en-US" sz="2000" dirty="0"/>
-              <a:t>: Extracted raw text from legal PDFs using PyMuPDF.</a:t>
+              <a:rPr lang="en-IN" b="1" dirty="0"/>
+              <a:t>Data Extraction:</a:t>
+            </a:r>
+            <a:r>
+              <a:rPr lang="en-IN" dirty="0"/>
+              <a:t> Extracted raw text from legal judgment PDFs using PyMuPDF (</a:t>
+            </a:r>
+            <a:r>
+              <a:rPr lang="en-IN" dirty="0" err="1"/>
+              <a:t>fitz</a:t>
+            </a:r>
+            <a:r>
+              <a:rPr lang="en-IN" dirty="0"/>
+              <a:t>), handling multi-page documents with complex formatting.</a:t>
             </a:r>
           </a:p>
           <a:p>
@@ -12003,12 +14596,12 @@
               <a:buChar char="•"/>
             </a:pPr>
             <a:r>
-              <a:rPr lang="en-US" sz="2000" b="1" dirty="0"/>
-              <a:t>Dynamic Translation</a:t>
-            </a:r>
-            <a:r>
-              <a:rPr lang="en-US" sz="2000" dirty="0"/>
-              <a:t>: Passed text through a JSON/Regex middleware to translate IPC references to BNS.</a:t>
+              <a:rPr lang="en-IN" b="1" dirty="0"/>
+              <a:t>Text Preprocessing:</a:t>
+            </a:r>
+            <a:r>
+              <a:rPr lang="en-IN" dirty="0"/>
+              <a:t> Applied custom Regex patterns to remove irrelevant metadata — CORAM, HEADNOTE, administrative headers — retaining only the substantive legal content.</a:t>
             </a:r>
           </a:p>
           <a:p>
@@ -12017,12 +14610,12 @@
               <a:buChar char="•"/>
             </a:pPr>
             <a:r>
-              <a:rPr lang="en-US" sz="2000" b="1" dirty="0"/>
-              <a:t>Structure-Aware Chunking</a:t>
-            </a:r>
-            <a:r>
-              <a:rPr lang="en-US" sz="2000" dirty="0"/>
-              <a:t>: Isolated strictly 'Facts' and 'Arguments' to feed the AI pure, unbiased context.</a:t>
+              <a:rPr lang="en-IN" b="1" dirty="0"/>
+              <a:t>Dynamic Translation:</a:t>
+            </a:r>
+            <a:r>
+              <a:rPr lang="en-IN" dirty="0"/>
+              <a:t> Passed cleaned text through a JSON-based IPC-to-BNS middleware that replaces legacy penal code references with their modern BNS equivalents (80+ mappings).</a:t>
             </a:r>
           </a:p>
           <a:p>
@@ -12031,12 +14624,12 @@
               <a:buChar char="•"/>
             </a:pPr>
             <a:r>
-              <a:rPr lang="en-US" sz="2000" b="1" dirty="0"/>
-              <a:t>InLegalBERT Execution</a:t>
-            </a:r>
-            <a:r>
-              <a:rPr lang="en-US" sz="2000" dirty="0"/>
-              <a:t>: Processed cleaned chunks through fine-tuned InLegalBERT for Jurisdiction and Outcome prediction.</a:t>
+              <a:rPr lang="en-IN" b="1" dirty="0"/>
+              <a:t>Structure-Aware Chunking:</a:t>
+            </a:r>
+            <a:r>
+              <a:rPr lang="en-IN" dirty="0"/>
+              <a:t> Isolated the three key sections — 'Facts', 'Arguments', and 'Judgment' — using domain-specific Regex patterns to feed the AI only pure, contextually relevant text.</a:t>
             </a:r>
           </a:p>
           <a:p>
@@ -12045,20 +14638,12 @@
               <a:buChar char="•"/>
             </a:pPr>
             <a:r>
-              <a:rPr lang="en-US" sz="2000" b="1" dirty="0"/>
-              <a:t>Explainable AI (XAI)</a:t>
-            </a:r>
-            <a:r>
-              <a:rPr lang="en-US" sz="2000" dirty="0"/>
-              <a:t>: Filtered SHAP outputs through </a:t>
-            </a:r>
-            <a:r>
-              <a:rPr lang="en-US" sz="2000" dirty="0" err="1"/>
-              <a:t>spaCy</a:t>
-            </a:r>
-            <a:r>
-              <a:rPr lang="en-US" sz="2000" dirty="0"/>
-              <a:t> NER to generate visual heatmaps of the exact decision-driving words.</a:t>
+              <a:rPr lang="en-IN" b="1" dirty="0"/>
+              <a:t>Dual-Model Inference:</a:t>
+            </a:r>
+            <a:r>
+              <a:rPr lang="en-IN" dirty="0"/>
+              <a:t> Processed extracted chunks through two separately fine-tuned InLegalBERT models — Module B for Jurisdiction classification (3-class) and Module C for Outcome prediction (binary).</a:t>
             </a:r>
           </a:p>
           <a:p>
@@ -12067,20 +14652,20 @@
               <a:buChar char="•"/>
             </a:pPr>
             <a:r>
-              <a:rPr lang="en-US" sz="2000" b="1" dirty="0"/>
-              <a:t>Secure SaaS Deployment</a:t>
-            </a:r>
-            <a:r>
-              <a:rPr lang="en-US" sz="2000" dirty="0"/>
-              <a:t>: Wrapped the entire pipeline in a Streamlit frontend with a </a:t>
-            </a:r>
-            <a:r>
-              <a:rPr lang="en-US" sz="2000" dirty="0" err="1"/>
+              <a:rPr lang="en-IN" b="1" dirty="0"/>
+              <a:t>Secure SaaS Deployment:</a:t>
+            </a:r>
+            <a:r>
+              <a:rPr lang="en-IN" dirty="0"/>
+              <a:t> Wrapped the entire pipeline in a Streamlit dashboard with </a:t>
+            </a:r>
+            <a:r>
+              <a:rPr lang="en-IN" dirty="0" err="1"/>
               <a:t>Supabase</a:t>
             </a:r>
             <a:r>
-              <a:rPr lang="en-US" sz="2000" dirty="0"/>
-              <a:t> PostgreSQL backend for encrypted lawyer authentication and case history tracking.</a:t>
+              <a:rPr lang="en-IN" dirty="0"/>
+              <a:t> PostgreSQL backend for role-based authentication, encrypted data storage, and prediction audit logging.</a:t>
             </a:r>
           </a:p>
         </p:txBody>
@@ -12093,7 +14678,7 @@
         </p:nvSpPr>
         <p:spPr>
           <a:xfrm>
-            <a:off x="190694" y="1526858"/>
+            <a:off x="190694" y="1340768"/>
             <a:ext cx="8843028" cy="584775"/>
           </a:xfrm>
           <a:prstGeom prst="rect">
@@ -12121,6 +14706,57 @@
               </a:rPr>
               <a:t>Methodology/ Workflow</a:t>
             </a:r>
+          </a:p>
+        </p:txBody>
+      </p:sp>
+      <p:sp>
+        <p:nvSpPr>
+          <p:cNvPr id="4" name="TextBox 7">
+            <a:extLst>
+              <a:ext uri="{FF2B5EF4-FFF2-40B4-BE49-F238E27FC236}">
+                <a16:creationId xmlns:a16="http://schemas.microsoft.com/office/drawing/2014/main" id="{0BBF89A4-B33C-1CD4-08D3-60A6FECC0E06}"/>
+              </a:ext>
+            </a:extLst>
+          </p:cNvPr>
+          <p:cNvSpPr txBox="1">
+            <a:spLocks noChangeArrowheads="1"/>
+          </p:cNvSpPr>
+          <p:nvPr/>
+        </p:nvSpPr>
+        <p:spPr bwMode="auto">
+          <a:xfrm>
+            <a:off x="0" y="1052735"/>
+            <a:ext cx="9180512" cy="338554"/>
+          </a:xfrm>
+          <a:prstGeom prst="rect">
+            <a:avLst/>
+          </a:prstGeom>
+          <a:solidFill>
+            <a:srgbClr val="FFC000"/>
+          </a:solidFill>
+          <a:ln w="9525">
+            <a:noFill/>
+            <a:miter lim="800000"/>
+          </a:ln>
+        </p:spPr>
+        <p:txBody>
+          <a:bodyPr wrap="square">
+            <a:spAutoFit/>
+          </a:bodyPr>
+          <a:lstStyle/>
+          <a:p>
+            <a:pPr algn="ctr"/>
+            <a:r>
+              <a:rPr lang="en-US" sz="1600" b="1" dirty="0">
+                <a:latin typeface="Times New Roman" panose="02020603050405020304" pitchFamily="18" charset="0"/>
+                <a:cs typeface="Times New Roman" panose="02020603050405020304" pitchFamily="18" charset="0"/>
+              </a:rPr>
+              <a:t>Final Presentation </a:t>
+            </a:r>
+            <a:endParaRPr lang="en-IN" sz="1600" b="1" dirty="0">
+              <a:latin typeface="Times New Roman" panose="02020603050405020304" pitchFamily="18" charset="0"/>
+              <a:cs typeface="Times New Roman" panose="02020603050405020304" pitchFamily="18" charset="0"/>
+            </a:endParaRPr>
           </a:p>
         </p:txBody>
       </p:sp>
@@ -12429,7 +15065,7 @@
         </p:nvSpPr>
         <p:spPr>
           <a:xfrm>
-            <a:off x="59285" y="1582511"/>
+            <a:off x="59285" y="1404065"/>
             <a:ext cx="9084715" cy="584775"/>
           </a:xfrm>
           <a:prstGeom prst="rect">
@@ -12496,6 +15132,57 @@
           </a:prstGeom>
         </p:spPr>
       </p:pic>
+      <p:sp>
+        <p:nvSpPr>
+          <p:cNvPr id="4" name="TextBox 7">
+            <a:extLst>
+              <a:ext uri="{FF2B5EF4-FFF2-40B4-BE49-F238E27FC236}">
+                <a16:creationId xmlns:a16="http://schemas.microsoft.com/office/drawing/2014/main" id="{D11A1D98-C075-1517-3064-CF4262088B55}"/>
+              </a:ext>
+            </a:extLst>
+          </p:cNvPr>
+          <p:cNvSpPr txBox="1">
+            <a:spLocks noChangeArrowheads="1"/>
+          </p:cNvSpPr>
+          <p:nvPr/>
+        </p:nvSpPr>
+        <p:spPr bwMode="auto">
+          <a:xfrm>
+            <a:off x="0" y="1052735"/>
+            <a:ext cx="9180512" cy="338554"/>
+          </a:xfrm>
+          <a:prstGeom prst="rect">
+            <a:avLst/>
+          </a:prstGeom>
+          <a:solidFill>
+            <a:srgbClr val="FFC000"/>
+          </a:solidFill>
+          <a:ln w="9525">
+            <a:noFill/>
+            <a:miter lim="800000"/>
+          </a:ln>
+        </p:spPr>
+        <p:txBody>
+          <a:bodyPr wrap="square">
+            <a:spAutoFit/>
+          </a:bodyPr>
+          <a:lstStyle/>
+          <a:p>
+            <a:pPr algn="ctr"/>
+            <a:r>
+              <a:rPr lang="en-US" sz="1600" b="1" dirty="0">
+                <a:latin typeface="Times New Roman" panose="02020603050405020304" pitchFamily="18" charset="0"/>
+                <a:cs typeface="Times New Roman" panose="02020603050405020304" pitchFamily="18" charset="0"/>
+              </a:rPr>
+              <a:t>Final Presentation </a:t>
+            </a:r>
+            <a:endParaRPr lang="en-IN" sz="1600" b="1" dirty="0">
+              <a:latin typeface="Times New Roman" panose="02020603050405020304" pitchFamily="18" charset="0"/>
+              <a:cs typeface="Times New Roman" panose="02020603050405020304" pitchFamily="18" charset="0"/>
+            </a:endParaRPr>
+          </a:p>
+        </p:txBody>
+      </p:sp>
     </p:spTree>
     <p:extLst>
       <p:ext uri="{BB962C8B-B14F-4D97-AF65-F5344CB8AC3E}">
@@ -12842,7 +15529,7 @@
         </p:nvSpPr>
         <p:spPr bwMode="auto">
           <a:xfrm>
-            <a:off x="251949" y="2251720"/>
+            <a:off x="251520" y="2251720"/>
             <a:ext cx="20836969" cy="457200"/>
           </a:xfrm>
           <a:prstGeom prst="rect">
@@ -14706,6 +17393,57 @@
           </a:graphicData>
         </a:graphic>
       </p:graphicFrame>
+      <p:sp>
+        <p:nvSpPr>
+          <p:cNvPr id="4" name="TextBox 7">
+            <a:extLst>
+              <a:ext uri="{FF2B5EF4-FFF2-40B4-BE49-F238E27FC236}">
+                <a16:creationId xmlns:a16="http://schemas.microsoft.com/office/drawing/2014/main" id="{ACCFCF9C-29DE-6922-A686-64EDF047208A}"/>
+              </a:ext>
+            </a:extLst>
+          </p:cNvPr>
+          <p:cNvSpPr txBox="1">
+            <a:spLocks noChangeArrowheads="1"/>
+          </p:cNvSpPr>
+          <p:nvPr/>
+        </p:nvSpPr>
+        <p:spPr bwMode="auto">
+          <a:xfrm>
+            <a:off x="0" y="1052735"/>
+            <a:ext cx="9180512" cy="338554"/>
+          </a:xfrm>
+          <a:prstGeom prst="rect">
+            <a:avLst/>
+          </a:prstGeom>
+          <a:solidFill>
+            <a:srgbClr val="FFC000"/>
+          </a:solidFill>
+          <a:ln w="9525">
+            <a:noFill/>
+            <a:miter lim="800000"/>
+          </a:ln>
+        </p:spPr>
+        <p:txBody>
+          <a:bodyPr wrap="square">
+            <a:spAutoFit/>
+          </a:bodyPr>
+          <a:lstStyle/>
+          <a:p>
+            <a:pPr algn="ctr"/>
+            <a:r>
+              <a:rPr lang="en-US" sz="1600" b="1" dirty="0">
+                <a:latin typeface="Times New Roman" panose="02020603050405020304" pitchFamily="18" charset="0"/>
+                <a:cs typeface="Times New Roman" panose="02020603050405020304" pitchFamily="18" charset="0"/>
+              </a:rPr>
+              <a:t>Final Presentation </a:t>
+            </a:r>
+            <a:endParaRPr lang="en-IN" sz="1600" b="1" dirty="0">
+              <a:latin typeface="Times New Roman" panose="02020603050405020304" pitchFamily="18" charset="0"/>
+              <a:cs typeface="Times New Roman" panose="02020603050405020304" pitchFamily="18" charset="0"/>
+            </a:endParaRPr>
+          </a:p>
+        </p:txBody>
+      </p:sp>
     </p:spTree>
     <p:extLst>
       <p:ext uri="{BB962C8B-B14F-4D97-AF65-F5344CB8AC3E}">
@@ -16426,6 +19164,57 @@
           </a:graphicData>
         </a:graphic>
       </p:graphicFrame>
+      <p:sp>
+        <p:nvSpPr>
+          <p:cNvPr id="3" name="TextBox 7">
+            <a:extLst>
+              <a:ext uri="{FF2B5EF4-FFF2-40B4-BE49-F238E27FC236}">
+                <a16:creationId xmlns:a16="http://schemas.microsoft.com/office/drawing/2014/main" id="{D0D8C393-C7BC-53EA-5F7F-A05205116A38}"/>
+              </a:ext>
+            </a:extLst>
+          </p:cNvPr>
+          <p:cNvSpPr txBox="1">
+            <a:spLocks noChangeArrowheads="1"/>
+          </p:cNvSpPr>
+          <p:nvPr/>
+        </p:nvSpPr>
+        <p:spPr bwMode="auto">
+          <a:xfrm>
+            <a:off x="0" y="1052735"/>
+            <a:ext cx="9180512" cy="338554"/>
+          </a:xfrm>
+          <a:prstGeom prst="rect">
+            <a:avLst/>
+          </a:prstGeom>
+          <a:solidFill>
+            <a:srgbClr val="FFC000"/>
+          </a:solidFill>
+          <a:ln w="9525">
+            <a:noFill/>
+            <a:miter lim="800000"/>
+          </a:ln>
+        </p:spPr>
+        <p:txBody>
+          <a:bodyPr wrap="square">
+            <a:spAutoFit/>
+          </a:bodyPr>
+          <a:lstStyle/>
+          <a:p>
+            <a:pPr algn="ctr"/>
+            <a:r>
+              <a:rPr lang="en-US" sz="1600" b="1" dirty="0">
+                <a:latin typeface="Times New Roman" panose="02020603050405020304" pitchFamily="18" charset="0"/>
+                <a:cs typeface="Times New Roman" panose="02020603050405020304" pitchFamily="18" charset="0"/>
+              </a:rPr>
+              <a:t>Final Presentation </a:t>
+            </a:r>
+            <a:endParaRPr lang="en-IN" sz="1600" b="1" dirty="0">
+              <a:latin typeface="Times New Roman" panose="02020603050405020304" pitchFamily="18" charset="0"/>
+              <a:cs typeface="Times New Roman" panose="02020603050405020304" pitchFamily="18" charset="0"/>
+            </a:endParaRPr>
+          </a:p>
+        </p:txBody>
+      </p:sp>
     </p:spTree>
     <p:extLst>
       <p:ext uri="{BB962C8B-B14F-4D97-AF65-F5344CB8AC3E}">

</xml_diff>